<commit_message>
feat: add comprehensive README and presentation guide for car fuel efficiency analysis project
</commit_message>
<xml_diff>
--- a/presentation_1/supervised_learning.pptx
+++ b/presentation_1/supervised_learning.pptx
@@ -16,9 +16,6 @@
     <p:sldId id="264" r:id="rId10"/>
     <p:sldId id="265" r:id="rId11"/>
     <p:sldId id="266" r:id="rId12"/>
-    <p:sldId id="267" r:id="rId13"/>
-    <p:sldId id="268" r:id="rId14"/>
-    <p:sldId id="269" r:id="rId15"/>
   </p:sldIdLst>
   <p:sldSz cx="9144000" cy="5143500" type="screen16x9"/>
   <p:notesSz cx="6858000" cy="9144000"/>
@@ -3128,7 +3125,7 @@
             </a:pPr>
             <a:r>
               <a:rPr/>
-              <a:t>Supervised Learning with mtcars Dataset</a:t>
+              <a:t>Understanding Car Fuel Efficiency</a:t>
             </a:r>
           </a:p>
         </p:txBody>
@@ -3158,7 +3155,7 @@
             </a:pPr>
             <a:r>
               <a:rPr/>
-              <a:t>A Comprehensive Analysis of Car Fuel Efficiency Prediction</a:t>
+              <a:t>A Data-Driven Analysis Using the mtcars Dataset</a:t>
             </a:r>
             <a:br/>
             <a:br/>
@@ -3193,6 +3190,31 @@
       </p:grpSpPr>
       <p:sp>
         <p:nvSpPr>
+          <p:cNvPr id="2" name="Title 1"/>
+          <p:cNvSpPr>
+            <a:spLocks noGrp="1"/>
+          </p:cNvSpPr>
+          <p:nvPr>
+            <p:ph type="title"/>
+          </p:nvPr>
+        </p:nvSpPr>
+        <p:spPr/>
+        <p:txBody>
+          <a:bodyPr/>
+          <a:lstStyle/>
+          <a:p>
+            <a:pPr lvl="0" indent="0" marL="0">
+              <a:buNone/>
+            </a:pPr>
+            <a:r>
+              <a:rPr/>
+              <a:t>Key Takeaways &amp; Next Steps</a:t>
+            </a:r>
+          </a:p>
+        </p:txBody>
+      </p:sp>
+      <p:sp>
+        <p:nvSpPr>
           <p:cNvPr id="3" name="Content Placeholder 2"/>
           <p:cNvSpPr>
             <a:spLocks noGrp="1"/>
@@ -3207,34 +3229,80 @@
           <a:lstStyle/>
           <a:p>
             <a:pPr lvl="0" indent="0" marL="0">
+              <a:spcBef>
+                <a:spcPts val="3000"/>
+              </a:spcBef>
               <a:buNone/>
             </a:pPr>
             <a:r>
               <a:rPr b="1"/>
-              <a:t>Selected Variables and Coefficients:</a:t>
-            </a:r>
-          </a:p>
-          <a:p>
-            <a:pPr lvl="0" indent="0">
-              <a:buNone/>
-            </a:pPr>
-            <a:r>
-              <a:rPr>
-                <a:latin typeface="Courier"/>
-              </a:rPr>
-              <a:t>11 x 1 sparse Matrix of class "dgCMatrix"
-                    s1
-(Intercept)  6.9840848
-cyl          .        
-disp         .        
-hp           .        
-drat         2.1555483
-wt          -2.8676564
-qsec         0.7922317
-vs           .        
-am           1.3174736
-gear         0.6218162
-carb        -0.6589320</a:t>
+              <a:t>Main Findings:</a:t>
+            </a:r>
+          </a:p>
+          <a:p>
+            <a:pPr lvl="0" indent="-342900" marL="342900">
+              <a:buAutoNum type="arabicPeriod"/>
+            </a:pPr>
+            <a:r>
+              <a:rPr/>
+              <a:t>Car Weight, Horsepower, and Transmission are key for MPG</a:t>
+            </a:r>
+          </a:p>
+          <a:p>
+            <a:pPr lvl="0" indent="-342900" marL="342900">
+              <a:buAutoNum type="arabicPeriod"/>
+            </a:pPr>
+            <a:r>
+              <a:rPr/>
+              <a:t>LASSO helps simplify models without losing accuracy</a:t>
+            </a:r>
+          </a:p>
+          <a:p>
+            <a:pPr lvl="0" indent="-342900" marL="342900">
+              <a:buAutoNum type="arabicPeriod"/>
+            </a:pPr>
+            <a:r>
+              <a:rPr/>
+              <a:t>Predictions are useful but have limits</a:t>
+            </a:r>
+          </a:p>
+          <a:p>
+            <a:pPr lvl="0" indent="0" marL="0">
+              <a:spcBef>
+                <a:spcPts val="3000"/>
+              </a:spcBef>
+              <a:buNone/>
+            </a:pPr>
+            <a:r>
+              <a:rPr b="1"/>
+              <a:t>Recommendations:</a:t>
+            </a:r>
+          </a:p>
+          <a:p>
+            <a:pPr lvl="0" indent="-342900" marL="342900">
+              <a:buAutoNum type="arabicPeriod"/>
+            </a:pPr>
+            <a:r>
+              <a:rPr/>
+              <a:t>Use modern car data for better insights</a:t>
+            </a:r>
+          </a:p>
+          <a:p>
+            <a:pPr lvl="0" indent="-342900" marL="342900">
+              <a:buAutoNum type="arabicPeriod"/>
+            </a:pPr>
+            <a:r>
+              <a:rPr/>
+              <a:t>Explore more advanced modeling techniques</a:t>
+            </a:r>
+          </a:p>
+          <a:p>
+            <a:pPr lvl="0" indent="-342900" marL="342900">
+              <a:buAutoNum type="arabicPeriod"/>
+            </a:pPr>
+            <a:r>
+              <a:rPr/>
+              <a:t>Always be cautious with predictions outside data range</a:t>
             </a:r>
           </a:p>
         </p:txBody>
@@ -3281,353 +3349,6 @@
             </a:pPr>
             <a:r>
               <a:rPr/>
-              <a:t>Model Performance Comparison</a:t>
-            </a:r>
-          </a:p>
-        </p:txBody>
-      </p:sp>
-      <p:sp>
-        <p:nvSpPr>
-          <p:cNvPr id="3" name="Content Placeholder 2"/>
-          <p:cNvSpPr>
-            <a:spLocks noGrp="1"/>
-          </p:cNvSpPr>
-          <p:nvPr>
-            <p:ph idx="1"/>
-          </p:nvPr>
-        </p:nvSpPr>
-        <p:spPr/>
-        <p:txBody>
-          <a:bodyPr/>
-          <a:lstStyle/>
-          <a:p>
-            <a:pPr lvl="0" indent="0" marL="0">
-              <a:spcBef>
-                <a:spcPts val="3000"/>
-              </a:spcBef>
-              <a:buNone/>
-            </a:pPr>
-            <a:r>
-              <a:rPr b="1"/>
-              <a:t>Comprehensive Metrics Analysis</a:t>
-            </a:r>
-          </a:p>
-          <a:p>
-            <a:pPr lvl="0" indent="0">
-              <a:buNone/>
-            </a:pPr>
-            <a:r>
-              <a:rPr>
-                <a:latin typeface="Courier"/>
-              </a:rPr>
-              <a:t>                     RMSE   MAE    R2
-Multiple Regression 2.663 2.214 0.807
-LASSO Regression    2.284 1.823 0.858</a:t>
-            </a:r>
-          </a:p>
-        </p:txBody>
-      </p:sp>
-    </p:spTree>
-  </p:cSld>
-</p:sld>
-</file>
-
-<file path=ppt/slides/slide12.xml><?xml version="1.0" encoding="utf-8"?>
-<p:sld xmlns:a="http://schemas.openxmlformats.org/drawingml/2006/main" xmlns:r="http://schemas.openxmlformats.org/officeDocument/2006/relationships" xmlns:p="http://schemas.openxmlformats.org/presentationml/2006/main">
-  <p:cSld>
-    <p:spTree>
-      <p:nvGrpSpPr>
-        <p:cNvPr id="1" name=""/>
-        <p:cNvGrpSpPr/>
-        <p:nvPr/>
-      </p:nvGrpSpPr>
-      <p:grpSpPr>
-        <a:xfrm>
-          <a:off x="0" y="0"/>
-          <a:ext cx="0" cy="0"/>
-          <a:chOff x="0" y="0"/>
-          <a:chExt cx="0" cy="0"/>
-        </a:xfrm>
-      </p:grpSpPr>
-      <p:sp>
-        <p:nvSpPr>
-          <p:cNvPr id="2" name="Title 1"/>
-          <p:cNvSpPr>
-            <a:spLocks noGrp="1"/>
-          </p:cNvSpPr>
-          <p:nvPr>
-            <p:ph type="title"/>
-          </p:nvPr>
-        </p:nvSpPr>
-        <p:spPr/>
-        <p:txBody>
-          <a:bodyPr/>
-          <a:lstStyle/>
-          <a:p>
-            <a:pPr lvl="0" indent="0" marL="0">
-              <a:buNone/>
-            </a:pPr>
-            <a:r>
-              <a:rPr/>
-              <a:t>Prediction Analysis</a:t>
-            </a:r>
-          </a:p>
-        </p:txBody>
-      </p:sp>
-      <p:sp>
-        <p:nvSpPr>
-          <p:cNvPr id="3" name="Content Placeholder 2"/>
-          <p:cNvSpPr>
-            <a:spLocks noGrp="1"/>
-          </p:cNvSpPr>
-          <p:nvPr>
-            <p:ph idx="1"/>
-          </p:nvPr>
-        </p:nvSpPr>
-        <p:spPr/>
-        <p:txBody>
-          <a:bodyPr/>
-          <a:lstStyle/>
-          <a:p>
-            <a:pPr lvl="0" indent="0" marL="0">
-              <a:spcBef>
-                <a:spcPts val="3000"/>
-              </a:spcBef>
-              <a:buNone/>
-            </a:pPr>
-            <a:r>
-              <a:rPr b="1"/>
-              <a:t>6000 lbs Car Case Study</a:t>
-            </a:r>
-          </a:p>
-          <a:p>
-            <a:pPr lvl="0" indent="0" marL="0">
-              <a:buNone/>
-            </a:pPr>
-            <a:r>
-              <a:rPr b="1"/>
-              <a:t>Prediction Setup:</a:t>
-            </a:r>
-            <a:r>
-              <a:rPr/>
-              <a:t> - Weight: 6000 lbs (wt = 6) - Other variables: Set to means</a:t>
-            </a:r>
-          </a:p>
-          <a:p>
-            <a:pPr lvl="0" indent="0" marL="0">
-              <a:buNone/>
-            </a:pPr>
-            <a:r>
-              <a:rPr b="1"/>
-              <a:t>Multiple Regression Prediction:</a:t>
-            </a:r>
-          </a:p>
-          <a:p>
-            <a:pPr lvl="0" indent="0">
-              <a:buNone/>
-            </a:pPr>
-            <a:r>
-              <a:rPr>
-                <a:latin typeface="Courier"/>
-              </a:rPr>
-              <a:t>Predicted MPG: 13.41</a:t>
-            </a:r>
-          </a:p>
-          <a:p>
-            <a:pPr lvl="0" indent="0">
-              <a:buNone/>
-            </a:pPr>
-            <a:r>
-              <a:rPr>
-                <a:latin typeface="Courier"/>
-              </a:rPr>
-              <a:t>95% Prediction Interval: (0.93, 25.88)</a:t>
-            </a:r>
-          </a:p>
-          <a:p>
-            <a:pPr lvl="0" indent="0" marL="0">
-              <a:buNone/>
-            </a:pPr>
-            <a:r>
-              <a:rPr b="1"/>
-              <a:t>Caution:</a:t>
-            </a:r>
-            <a:r>
-              <a:rPr/>
-              <a:t> This is an extrapolation! - Training data weight range: 1.51, 5.34 - Prediction reliability decreases</a:t>
-            </a:r>
-          </a:p>
-        </p:txBody>
-      </p:sp>
-    </p:spTree>
-  </p:cSld>
-</p:sld>
-</file>
-
-<file path=ppt/slides/slide13.xml><?xml version="1.0" encoding="utf-8"?>
-<p:sld xmlns:a="http://schemas.openxmlformats.org/drawingml/2006/main" xmlns:r="http://schemas.openxmlformats.org/officeDocument/2006/relationships" xmlns:p="http://schemas.openxmlformats.org/presentationml/2006/main">
-  <p:cSld>
-    <p:spTree>
-      <p:nvGrpSpPr>
-        <p:cNvPr id="1" name=""/>
-        <p:cNvGrpSpPr/>
-        <p:nvPr/>
-      </p:nvGrpSpPr>
-      <p:grpSpPr>
-        <a:xfrm>
-          <a:off x="0" y="0"/>
-          <a:ext cx="0" cy="0"/>
-          <a:chOff x="0" y="0"/>
-          <a:chExt cx="0" cy="0"/>
-        </a:xfrm>
-      </p:grpSpPr>
-      <p:sp>
-        <p:nvSpPr>
-          <p:cNvPr id="2" name="Title 1"/>
-          <p:cNvSpPr>
-            <a:spLocks noGrp="1"/>
-          </p:cNvSpPr>
-          <p:nvPr>
-            <p:ph type="title"/>
-          </p:nvPr>
-        </p:nvSpPr>
-        <p:spPr/>
-        <p:txBody>
-          <a:bodyPr/>
-          <a:lstStyle/>
-          <a:p>
-            <a:pPr lvl="0" indent="0" marL="0">
-              <a:buNone/>
-            </a:pPr>
-            <a:r>
-              <a:rPr/>
-              <a:t>Comprehensive Recommendations</a:t>
-            </a:r>
-          </a:p>
-        </p:txBody>
-      </p:sp>
-      <p:sp>
-        <p:nvSpPr>
-          <p:cNvPr id="3" name="Content Placeholder 2"/>
-          <p:cNvSpPr>
-            <a:spLocks noGrp="1"/>
-          </p:cNvSpPr>
-          <p:nvPr>
-            <p:ph idx="1"/>
-          </p:nvPr>
-        </p:nvSpPr>
-        <p:spPr/>
-        <p:txBody>
-          <a:bodyPr/>
-          <a:lstStyle/>
-          <a:p>
-            <a:pPr lvl="0" indent="0" marL="0">
-              <a:spcBef>
-                <a:spcPts val="3000"/>
-              </a:spcBef>
-              <a:buNone/>
-            </a:pPr>
-            <a:r>
-              <a:rPr b="1"/>
-              <a:t>Data Science Approach</a:t>
-            </a:r>
-          </a:p>
-          <a:p>
-            <a:pPr lvl="0" indent="0" marL="0">
-              <a:buNone/>
-            </a:pPr>
-            <a:r>
-              <a:rPr b="1"/>
-              <a:t>1. Data Quality Improvements:</a:t>
-            </a:r>
-            <a:r>
-              <a:rPr/>
-              <a:t> - Collect modern car data - Include hybrid/electric vehicles - Expand feature set (aerodynamics, tech)</a:t>
-            </a:r>
-          </a:p>
-          <a:p>
-            <a:pPr lvl="0" indent="0" marL="0">
-              <a:buNone/>
-            </a:pPr>
-            <a:r>
-              <a:rPr b="1"/>
-              <a:t>2. Modeling Enhancements:</a:t>
-            </a:r>
-            <a:r>
-              <a:rPr/>
-              <a:t> - Consider non-linear relationships - Explore interaction terms - Implement robust regression</a:t>
-            </a:r>
-          </a:p>
-          <a:p>
-            <a:pPr lvl="0" indent="0" marL="0">
-              <a:buNone/>
-            </a:pPr>
-            <a:r>
-              <a:rPr b="1"/>
-              <a:t>3. Practical Implementation:</a:t>
-            </a:r>
-            <a:r>
-              <a:rPr/>
-              <a:t> - Regular model updates - Confidence interval reporting - Extrapolation warnings</a:t>
-            </a:r>
-          </a:p>
-          <a:p>
-            <a:pPr lvl="0" indent="0" marL="0">
-              <a:buNone/>
-            </a:pPr>
-            <a:r>
-              <a:rPr b="1"/>
-              <a:t>4. Future Considerations:</a:t>
-            </a:r>
-            <a:r>
-              <a:rPr/>
-              <a:t> - Alternative algorithms (RF, GBM) - Cross-validation strategies - Feature engineering</a:t>
-            </a:r>
-          </a:p>
-        </p:txBody>
-      </p:sp>
-    </p:spTree>
-  </p:cSld>
-</p:sld>
-</file>
-
-<file path=ppt/slides/slide14.xml><?xml version="1.0" encoding="utf-8"?>
-<p:sld xmlns:a="http://schemas.openxmlformats.org/drawingml/2006/main" xmlns:r="http://schemas.openxmlformats.org/officeDocument/2006/relationships" xmlns:p="http://schemas.openxmlformats.org/presentationml/2006/main">
-  <p:cSld>
-    <p:spTree>
-      <p:nvGrpSpPr>
-        <p:cNvPr id="1" name=""/>
-        <p:cNvGrpSpPr/>
-        <p:nvPr/>
-      </p:nvGrpSpPr>
-      <p:grpSpPr>
-        <a:xfrm>
-          <a:off x="0" y="0"/>
-          <a:ext cx="0" cy="0"/>
-          <a:chOff x="0" y="0"/>
-          <a:chExt cx="0" cy="0"/>
-        </a:xfrm>
-      </p:grpSpPr>
-      <p:sp>
-        <p:nvSpPr>
-          <p:cNvPr id="2" name="Title 1"/>
-          <p:cNvSpPr>
-            <a:spLocks noGrp="1"/>
-          </p:cNvSpPr>
-          <p:nvPr>
-            <p:ph type="title"/>
-          </p:nvPr>
-        </p:nvSpPr>
-        <p:spPr/>
-        <p:txBody>
-          <a:bodyPr/>
-          <a:lstStyle/>
-          <a:p>
-            <a:pPr lvl="0" indent="0" marL="0">
-              <a:buNone/>
-            </a:pPr>
-            <a:r>
-              <a:rPr/>
               <a:t>Questions?</a:t>
             </a:r>
           </a:p>
@@ -3705,7 +3426,7 @@
             </a:pPr>
             <a:r>
               <a:rPr/>
-              <a:t>Dataset Overview</a:t>
+              <a:t>Understanding Our Data</a:t>
             </a:r>
           </a:p>
         </p:txBody>
@@ -3733,7 +3454,7 @@
             </a:pPr>
             <a:r>
               <a:rPr b="1"/>
-              <a:t>Motor Trend Car Road Tests (1974)</a:t>
+              <a:t>About the Car Dataset</a:t>
             </a:r>
           </a:p>
           <a:p>
@@ -3742,11 +3463,11 @@
             </a:pPr>
             <a:r>
               <a:rPr b="1"/>
-              <a:t>Dataset Characteristics:</a:t>
+              <a:t>What We’re Working With:</a:t>
             </a:r>
             <a:r>
               <a:rPr/>
-              <a:t> - 32 automobiles (1973-74 models) - 11 key variables measuring various aspects - Focus: Understanding fuel efficiency (MPG)</a:t>
+              <a:t> - 32 different car models from 1973-74 - Focus: How car features affect fuel efficiency - Goal: Predict miles per gallon (MPG)</a:t>
             </a:r>
           </a:p>
           <a:p>
@@ -3755,11 +3476,27 @@
             </a:pPr>
             <a:r>
               <a:rPr b="1"/>
-              <a:t>Variables in Detail:</a:t>
+              <a:t>Key Car Features:</a:t>
             </a:r>
             <a:r>
               <a:rPr/>
-              <a:t> - MPG (Dependent): Miles per gallon - CYL: Number of cylinders (4, 6, 8) - DISP: Engine displacement (cu.in.) - HP: Gross horsepower - DRAT: Rear axle ratio - WT: Weight (1000 lbs) - QSEC: 1/4 mile time - VS: Engine type (V/Straight) - AM: Transmission type (Auto/Manual) - GEAR: Number of forward gears - CARB: Number of carburetors</a:t>
+              <a:t> - </a:t>
+            </a:r>
+            <a:r>
+              <a:rPr b="1"/>
+              <a:t>Engine Stats:</a:t>
+            </a:r>
+            <a:r>
+              <a:rPr/>
+              <a:t> * Number of cylinders (4, 6, or 8) * Engine size (displacement) * Horsepower - </a:t>
+            </a:r>
+            <a:r>
+              <a:rPr b="1"/>
+              <a:t>Physical Features:</a:t>
+            </a:r>
+            <a:r>
+              <a:rPr/>
+              <a:t> * Car weight (in 1000 lbs) * Transmission type (Auto/Manual)</a:t>
             </a:r>
           </a:p>
         </p:txBody>
@@ -3868,6 +3605,697 @@
             </a:r>
           </a:p>
           <a:p>
+            <a:pPr lvl="0" indent="0">
+              <a:buNone/>
+            </a:pPr>
+            <a:r>
+              <a:rPr>
+                <a:solidFill>
+                  <a:srgbClr val="4758AB"/>
+                </a:solidFill>
+                <a:latin typeface="Courier"/>
+              </a:rPr>
+              <a:t>library</a:t>
+            </a:r>
+            <a:r>
+              <a:rPr>
+                <a:solidFill>
+                  <a:srgbClr val="003B4F"/>
+                </a:solidFill>
+                <a:latin typeface="Courier"/>
+              </a:rPr>
+              <a:t>(datasets)</a:t>
+            </a:r>
+            <a:br/>
+            <a:r>
+              <a:rPr>
+                <a:solidFill>
+                  <a:srgbClr val="4758AB"/>
+                </a:solidFill>
+                <a:latin typeface="Courier"/>
+              </a:rPr>
+              <a:t>library</a:t>
+            </a:r>
+            <a:r>
+              <a:rPr>
+                <a:solidFill>
+                  <a:srgbClr val="003B4F"/>
+                </a:solidFill>
+                <a:latin typeface="Courier"/>
+              </a:rPr>
+              <a:t>(glmnet)</a:t>
+            </a:r>
+            <a:br/>
+            <a:r>
+              <a:rPr>
+                <a:solidFill>
+                  <a:srgbClr val="4758AB"/>
+                </a:solidFill>
+                <a:latin typeface="Courier"/>
+              </a:rPr>
+              <a:t>set.seed</a:t>
+            </a:r>
+            <a:r>
+              <a:rPr>
+                <a:solidFill>
+                  <a:srgbClr val="003B4F"/>
+                </a:solidFill>
+                <a:latin typeface="Courier"/>
+              </a:rPr>
+              <a:t>(</a:t>
+            </a:r>
+            <a:r>
+              <a:rPr>
+                <a:solidFill>
+                  <a:srgbClr val="AD0000"/>
+                </a:solidFill>
+                <a:latin typeface="Courier"/>
+              </a:rPr>
+              <a:t>17</a:t>
+            </a:r>
+            <a:r>
+              <a:rPr>
+                <a:solidFill>
+                  <a:srgbClr val="003B4F"/>
+                </a:solidFill>
+                <a:latin typeface="Courier"/>
+              </a:rPr>
+              <a:t>)</a:t>
+            </a:r>
+            <a:br/>
+            <a:br/>
+            <a:r>
+              <a:rPr>
+                <a:solidFill>
+                  <a:srgbClr val="5E5E5E"/>
+                </a:solidFill>
+                <a:latin typeface="Courier"/>
+              </a:rPr>
+              <a:t># Data preparation</a:t>
+            </a:r>
+            <a:br/>
+            <a:r>
+              <a:rPr>
+                <a:solidFill>
+                  <a:srgbClr val="003B4F"/>
+                </a:solidFill>
+                <a:latin typeface="Courier"/>
+              </a:rPr>
+              <a:t>train_index &lt;- </a:t>
+            </a:r>
+            <a:r>
+              <a:rPr>
+                <a:solidFill>
+                  <a:srgbClr val="4758AB"/>
+                </a:solidFill>
+                <a:latin typeface="Courier"/>
+              </a:rPr>
+              <a:t>sample</a:t>
+            </a:r>
+            <a:r>
+              <a:rPr>
+                <a:solidFill>
+                  <a:srgbClr val="003B4F"/>
+                </a:solidFill>
+                <a:latin typeface="Courier"/>
+              </a:rPr>
+              <a:t>(</a:t>
+            </a:r>
+            <a:r>
+              <a:rPr>
+                <a:solidFill>
+                  <a:srgbClr val="AD0000"/>
+                </a:solidFill>
+                <a:latin typeface="Courier"/>
+              </a:rPr>
+              <a:t>2</a:t>
+            </a:r>
+            <a:r>
+              <a:rPr>
+                <a:solidFill>
+                  <a:srgbClr val="003B4F"/>
+                </a:solidFill>
+                <a:latin typeface="Courier"/>
+              </a:rPr>
+              <a:t>, </a:t>
+            </a:r>
+            <a:r>
+              <a:rPr>
+                <a:solidFill>
+                  <a:srgbClr val="4758AB"/>
+                </a:solidFill>
+                <a:latin typeface="Courier"/>
+              </a:rPr>
+              <a:t>nrow</a:t>
+            </a:r>
+            <a:r>
+              <a:rPr>
+                <a:solidFill>
+                  <a:srgbClr val="003B4F"/>
+                </a:solidFill>
+                <a:latin typeface="Courier"/>
+              </a:rPr>
+              <a:t>(mtcars), </a:t>
+            </a:r>
+            <a:r>
+              <a:rPr>
+                <a:solidFill>
+                  <a:srgbClr val="657422"/>
+                </a:solidFill>
+                <a:latin typeface="Courier"/>
+              </a:rPr>
+              <a:t>replace =</a:t>
+            </a:r>
+            <a:r>
+              <a:rPr>
+                <a:solidFill>
+                  <a:srgbClr val="003B4F"/>
+                </a:solidFill>
+                <a:latin typeface="Courier"/>
+              </a:rPr>
+              <a:t> T, </a:t>
+            </a:r>
+            <a:r>
+              <a:rPr>
+                <a:solidFill>
+                  <a:srgbClr val="657422"/>
+                </a:solidFill>
+                <a:latin typeface="Courier"/>
+              </a:rPr>
+              <a:t>prob =</a:t>
+            </a:r>
+            <a:r>
+              <a:rPr>
+                <a:solidFill>
+                  <a:srgbClr val="003B4F"/>
+                </a:solidFill>
+                <a:latin typeface="Courier"/>
+              </a:rPr>
+              <a:t> </a:t>
+            </a:r>
+            <a:r>
+              <a:rPr>
+                <a:solidFill>
+                  <a:srgbClr val="4758AB"/>
+                </a:solidFill>
+                <a:latin typeface="Courier"/>
+              </a:rPr>
+              <a:t>c</a:t>
+            </a:r>
+            <a:r>
+              <a:rPr>
+                <a:solidFill>
+                  <a:srgbClr val="003B4F"/>
+                </a:solidFill>
+                <a:latin typeface="Courier"/>
+              </a:rPr>
+              <a:t>(</a:t>
+            </a:r>
+            <a:r>
+              <a:rPr>
+                <a:solidFill>
+                  <a:srgbClr val="AD0000"/>
+                </a:solidFill>
+                <a:latin typeface="Courier"/>
+              </a:rPr>
+              <a:t>0.7</a:t>
+            </a:r>
+            <a:r>
+              <a:rPr>
+                <a:solidFill>
+                  <a:srgbClr val="003B4F"/>
+                </a:solidFill>
+                <a:latin typeface="Courier"/>
+              </a:rPr>
+              <a:t>, </a:t>
+            </a:r>
+            <a:r>
+              <a:rPr>
+                <a:solidFill>
+                  <a:srgbClr val="AD0000"/>
+                </a:solidFill>
+                <a:latin typeface="Courier"/>
+              </a:rPr>
+              <a:t>0.3</a:t>
+            </a:r>
+            <a:r>
+              <a:rPr>
+                <a:solidFill>
+                  <a:srgbClr val="003B4F"/>
+                </a:solidFill>
+                <a:latin typeface="Courier"/>
+              </a:rPr>
+              <a:t>))</a:t>
+            </a:r>
+            <a:br/>
+            <a:r>
+              <a:rPr>
+                <a:solidFill>
+                  <a:srgbClr val="003B4F"/>
+                </a:solidFill>
+                <a:latin typeface="Courier"/>
+              </a:rPr>
+              <a:t>train_data &lt;- mtcars[train_index</a:t>
+            </a:r>
+            <a:r>
+              <a:rPr>
+                <a:solidFill>
+                  <a:srgbClr val="5E5E5E"/>
+                </a:solidFill>
+                <a:latin typeface="Courier"/>
+              </a:rPr>
+              <a:t>==</a:t>
+            </a:r>
+            <a:r>
+              <a:rPr>
+                <a:solidFill>
+                  <a:srgbClr val="AD0000"/>
+                </a:solidFill>
+                <a:latin typeface="Courier"/>
+              </a:rPr>
+              <a:t>1</a:t>
+            </a:r>
+            <a:r>
+              <a:rPr>
+                <a:solidFill>
+                  <a:srgbClr val="003B4F"/>
+                </a:solidFill>
+                <a:latin typeface="Courier"/>
+              </a:rPr>
+              <a:t>, ]</a:t>
+            </a:r>
+            <a:br/>
+            <a:r>
+              <a:rPr>
+                <a:solidFill>
+                  <a:srgbClr val="003B4F"/>
+                </a:solidFill>
+                <a:latin typeface="Courier"/>
+              </a:rPr>
+              <a:t>test_data &lt;- mtcars[train_index</a:t>
+            </a:r>
+            <a:r>
+              <a:rPr>
+                <a:solidFill>
+                  <a:srgbClr val="5E5E5E"/>
+                </a:solidFill>
+                <a:latin typeface="Courier"/>
+              </a:rPr>
+              <a:t>==</a:t>
+            </a:r>
+            <a:r>
+              <a:rPr>
+                <a:solidFill>
+                  <a:srgbClr val="AD0000"/>
+                </a:solidFill>
+                <a:latin typeface="Courier"/>
+              </a:rPr>
+              <a:t>2</a:t>
+            </a:r>
+            <a:r>
+              <a:rPr>
+                <a:solidFill>
+                  <a:srgbClr val="003B4F"/>
+                </a:solidFill>
+                <a:latin typeface="Courier"/>
+              </a:rPr>
+              <a:t>, ]</a:t>
+            </a:r>
+            <a:br/>
+            <a:br/>
+            <a:r>
+              <a:rPr>
+                <a:solidFill>
+                  <a:srgbClr val="5E5E5E"/>
+                </a:solidFill>
+                <a:latin typeface="Courier"/>
+              </a:rPr>
+              <a:t># Ensure train_data is properly defined in global environment</a:t>
+            </a:r>
+            <a:br/>
+            <a:r>
+              <a:rPr>
+                <a:solidFill>
+                  <a:srgbClr val="4758AB"/>
+                </a:solidFill>
+                <a:latin typeface="Courier"/>
+              </a:rPr>
+              <a:t>assign</a:t>
+            </a:r>
+            <a:r>
+              <a:rPr>
+                <a:solidFill>
+                  <a:srgbClr val="003B4F"/>
+                </a:solidFill>
+                <a:latin typeface="Courier"/>
+              </a:rPr>
+              <a:t>(</a:t>
+            </a:r>
+            <a:r>
+              <a:rPr>
+                <a:solidFill>
+                  <a:srgbClr val="20794D"/>
+                </a:solidFill>
+                <a:latin typeface="Courier"/>
+              </a:rPr>
+              <a:t>"train_data"</a:t>
+            </a:r>
+            <a:r>
+              <a:rPr>
+                <a:solidFill>
+                  <a:srgbClr val="003B4F"/>
+                </a:solidFill>
+                <a:latin typeface="Courier"/>
+              </a:rPr>
+              <a:t>, train_data, </a:t>
+            </a:r>
+            <a:r>
+              <a:rPr>
+                <a:solidFill>
+                  <a:srgbClr val="657422"/>
+                </a:solidFill>
+                <a:latin typeface="Courier"/>
+              </a:rPr>
+              <a:t>envir =</a:t>
+            </a:r>
+            <a:r>
+              <a:rPr>
+                <a:solidFill>
+                  <a:srgbClr val="003B4F"/>
+                </a:solidFill>
+                <a:latin typeface="Courier"/>
+              </a:rPr>
+              <a:t> .GlobalEnv)</a:t>
+            </a:r>
+            <a:br/>
+            <a:r>
+              <a:rPr>
+                <a:solidFill>
+                  <a:srgbClr val="4758AB"/>
+                </a:solidFill>
+                <a:latin typeface="Courier"/>
+              </a:rPr>
+              <a:t>assign</a:t>
+            </a:r>
+            <a:r>
+              <a:rPr>
+                <a:solidFill>
+                  <a:srgbClr val="003B4F"/>
+                </a:solidFill>
+                <a:latin typeface="Courier"/>
+              </a:rPr>
+              <a:t>(</a:t>
+            </a:r>
+            <a:r>
+              <a:rPr>
+                <a:solidFill>
+                  <a:srgbClr val="20794D"/>
+                </a:solidFill>
+                <a:latin typeface="Courier"/>
+              </a:rPr>
+              <a:t>"test_data"</a:t>
+            </a:r>
+            <a:r>
+              <a:rPr>
+                <a:solidFill>
+                  <a:srgbClr val="003B4F"/>
+                </a:solidFill>
+                <a:latin typeface="Courier"/>
+              </a:rPr>
+              <a:t>, test_data, </a:t>
+            </a:r>
+            <a:r>
+              <a:rPr>
+                <a:solidFill>
+                  <a:srgbClr val="657422"/>
+                </a:solidFill>
+                <a:latin typeface="Courier"/>
+              </a:rPr>
+              <a:t>envir =</a:t>
+            </a:r>
+            <a:r>
+              <a:rPr>
+                <a:solidFill>
+                  <a:srgbClr val="003B4F"/>
+                </a:solidFill>
+                <a:latin typeface="Courier"/>
+              </a:rPr>
+              <a:t> .GlobalEnv)</a:t>
+            </a:r>
+            <a:br/>
+            <a:br/>
+            <a:r>
+              <a:rPr>
+                <a:solidFill>
+                  <a:srgbClr val="5E5E5E"/>
+                </a:solidFill>
+                <a:latin typeface="Courier"/>
+              </a:rPr>
+              <a:t># Prepare LASSO matrices once</a:t>
+            </a:r>
+            <a:br/>
+            <a:r>
+              <a:rPr>
+                <a:solidFill>
+                  <a:srgbClr val="003B4F"/>
+                </a:solidFill>
+                <a:latin typeface="Courier"/>
+              </a:rPr>
+              <a:t>predictors &lt;- </a:t>
+            </a:r>
+            <a:r>
+              <a:rPr>
+                <a:solidFill>
+                  <a:srgbClr val="4758AB"/>
+                </a:solidFill>
+                <a:latin typeface="Courier"/>
+              </a:rPr>
+              <a:t>setdiff</a:t>
+            </a:r>
+            <a:r>
+              <a:rPr>
+                <a:solidFill>
+                  <a:srgbClr val="003B4F"/>
+                </a:solidFill>
+                <a:latin typeface="Courier"/>
+              </a:rPr>
+              <a:t>(</a:t>
+            </a:r>
+            <a:r>
+              <a:rPr>
+                <a:solidFill>
+                  <a:srgbClr val="4758AB"/>
+                </a:solidFill>
+                <a:latin typeface="Courier"/>
+              </a:rPr>
+              <a:t>names</a:t>
+            </a:r>
+            <a:r>
+              <a:rPr>
+                <a:solidFill>
+                  <a:srgbClr val="003B4F"/>
+                </a:solidFill>
+                <a:latin typeface="Courier"/>
+              </a:rPr>
+              <a:t>(train_data), </a:t>
+            </a:r>
+            <a:r>
+              <a:rPr>
+                <a:solidFill>
+                  <a:srgbClr val="20794D"/>
+                </a:solidFill>
+                <a:latin typeface="Courier"/>
+              </a:rPr>
+              <a:t>"mpg"</a:t>
+            </a:r>
+            <a:r>
+              <a:rPr>
+                <a:solidFill>
+                  <a:srgbClr val="003B4F"/>
+                </a:solidFill>
+                <a:latin typeface="Courier"/>
+              </a:rPr>
+              <a:t>)</a:t>
+            </a:r>
+            <a:br/>
+            <a:r>
+              <a:rPr>
+                <a:solidFill>
+                  <a:srgbClr val="003B4F"/>
+                </a:solidFill>
+                <a:latin typeface="Courier"/>
+              </a:rPr>
+              <a:t>x_train &lt;- </a:t>
+            </a:r>
+            <a:r>
+              <a:rPr>
+                <a:solidFill>
+                  <a:srgbClr val="4758AB"/>
+                </a:solidFill>
+                <a:latin typeface="Courier"/>
+              </a:rPr>
+              <a:t>as.matrix</a:t>
+            </a:r>
+            <a:r>
+              <a:rPr>
+                <a:solidFill>
+                  <a:srgbClr val="003B4F"/>
+                </a:solidFill>
+                <a:latin typeface="Courier"/>
+              </a:rPr>
+              <a:t>(train_data[, predictors])</a:t>
+            </a:r>
+            <a:br/>
+            <a:r>
+              <a:rPr>
+                <a:solidFill>
+                  <a:srgbClr val="003B4F"/>
+                </a:solidFill>
+                <a:latin typeface="Courier"/>
+              </a:rPr>
+              <a:t>y_train &lt;- train_data</a:t>
+            </a:r>
+            <a:r>
+              <a:rPr>
+                <a:solidFill>
+                  <a:srgbClr val="5E5E5E"/>
+                </a:solidFill>
+                <a:latin typeface="Courier"/>
+              </a:rPr>
+              <a:t>$</a:t>
+            </a:r>
+            <a:r>
+              <a:rPr>
+                <a:solidFill>
+                  <a:srgbClr val="003B4F"/>
+                </a:solidFill>
+                <a:latin typeface="Courier"/>
+              </a:rPr>
+              <a:t>mpg</a:t>
+            </a:r>
+            <a:br/>
+            <a:br/>
+            <a:r>
+              <a:rPr>
+                <a:solidFill>
+                  <a:srgbClr val="5E5E5E"/>
+                </a:solidFill>
+                <a:latin typeface="Courier"/>
+              </a:rPr>
+              <a:t># Define these in global environment for later use</a:t>
+            </a:r>
+            <a:br/>
+            <a:r>
+              <a:rPr>
+                <a:solidFill>
+                  <a:srgbClr val="4758AB"/>
+                </a:solidFill>
+                <a:latin typeface="Courier"/>
+              </a:rPr>
+              <a:t>assign</a:t>
+            </a:r>
+            <a:r>
+              <a:rPr>
+                <a:solidFill>
+                  <a:srgbClr val="003B4F"/>
+                </a:solidFill>
+                <a:latin typeface="Courier"/>
+              </a:rPr>
+              <a:t>(</a:t>
+            </a:r>
+            <a:r>
+              <a:rPr>
+                <a:solidFill>
+                  <a:srgbClr val="20794D"/>
+                </a:solidFill>
+                <a:latin typeface="Courier"/>
+              </a:rPr>
+              <a:t>"x_train"</a:t>
+            </a:r>
+            <a:r>
+              <a:rPr>
+                <a:solidFill>
+                  <a:srgbClr val="003B4F"/>
+                </a:solidFill>
+                <a:latin typeface="Courier"/>
+              </a:rPr>
+              <a:t>, x_train, </a:t>
+            </a:r>
+            <a:r>
+              <a:rPr>
+                <a:solidFill>
+                  <a:srgbClr val="657422"/>
+                </a:solidFill>
+                <a:latin typeface="Courier"/>
+              </a:rPr>
+              <a:t>envir =</a:t>
+            </a:r>
+            <a:r>
+              <a:rPr>
+                <a:solidFill>
+                  <a:srgbClr val="003B4F"/>
+                </a:solidFill>
+                <a:latin typeface="Courier"/>
+              </a:rPr>
+              <a:t> .GlobalEnv)</a:t>
+            </a:r>
+            <a:br/>
+            <a:r>
+              <a:rPr>
+                <a:solidFill>
+                  <a:srgbClr val="4758AB"/>
+                </a:solidFill>
+                <a:latin typeface="Courier"/>
+              </a:rPr>
+              <a:t>assign</a:t>
+            </a:r>
+            <a:r>
+              <a:rPr>
+                <a:solidFill>
+                  <a:srgbClr val="003B4F"/>
+                </a:solidFill>
+                <a:latin typeface="Courier"/>
+              </a:rPr>
+              <a:t>(</a:t>
+            </a:r>
+            <a:r>
+              <a:rPr>
+                <a:solidFill>
+                  <a:srgbClr val="20794D"/>
+                </a:solidFill>
+                <a:latin typeface="Courier"/>
+              </a:rPr>
+              <a:t>"y_train"</a:t>
+            </a:r>
+            <a:r>
+              <a:rPr>
+                <a:solidFill>
+                  <a:srgbClr val="003B4F"/>
+                </a:solidFill>
+                <a:latin typeface="Courier"/>
+              </a:rPr>
+              <a:t>, y_train, </a:t>
+            </a:r>
+            <a:r>
+              <a:rPr>
+                <a:solidFill>
+                  <a:srgbClr val="657422"/>
+                </a:solidFill>
+                <a:latin typeface="Courier"/>
+              </a:rPr>
+              <a:t>envir =</a:t>
+            </a:r>
+            <a:r>
+              <a:rPr>
+                <a:solidFill>
+                  <a:srgbClr val="003B4F"/>
+                </a:solidFill>
+                <a:latin typeface="Courier"/>
+              </a:rPr>
+              <a:t> .GlobalEnv)</a:t>
+            </a:r>
+          </a:p>
+          <a:p>
             <a:pPr lvl="0" indent="0" marL="0">
               <a:buNone/>
             </a:pPr>
@@ -4011,9 +4439,10 @@
               <a:rPr>
                 <a:latin typeface="Courier"/>
               </a:rPr>
-              <a:t>cyl: 73.2% (p = 0.0000)
-wt: 73.2% (p = 0.0000)
-disp: 67.9% (p = 0.0000)</a:t>
+              <a:t>cyl: 73.2% (p = 0.0000014968)
+wt: 73.2% (p = 0.0000015375)
+disp: 67.9% (p = 0.0000080226)
+hp: 56.8% (p = 0.0001238260)</a:t>
             </a:r>
           </a:p>
           <a:p>
@@ -4089,12 +4518,7 @@
             <p:ph type="title"/>
           </p:nvPr>
         </p:nvSpPr>
-        <p:spPr>
-          <a:xfrm>
-            <a:off x="457201" y="204787"/>
-            <a:ext cx="3008313" cy="871538"/>
-          </a:xfrm>
-        </p:spPr>
+        <p:spPr/>
         <p:txBody>
           <a:bodyPr/>
           <a:lstStyle/>
@@ -4104,19 +4528,19 @@
             </a:pPr>
             <a:r>
               <a:rPr/>
-              <a:t>BLUE Analysis - Part 1</a:t>
-            </a:r>
-          </a:p>
-        </p:txBody>
-      </p:sp>
-      <p:sp>
-        <p:nvSpPr>
-          <p:cNvPr id="4" name="Text Placeholder 3"/>
-          <p:cNvSpPr>
-            <a:spLocks noGrp="1"/>
-          </p:cNvSpPr>
-          <p:nvPr>
-            <p:ph idx="2" sz="half" type="body"/>
+              <a:t>Most Important Car Features</a:t>
+            </a:r>
+          </a:p>
+        </p:txBody>
+      </p:sp>
+      <p:sp>
+        <p:nvSpPr>
+          <p:cNvPr id="3" name="Content Placeholder 2"/>
+          <p:cNvSpPr>
+            <a:spLocks noGrp="1"/>
+          </p:cNvSpPr>
+          <p:nvPr>
+            <p:ph idx="1"/>
           </p:nvPr>
         </p:nvSpPr>
         <p:spPr/>
@@ -4132,7 +4556,7 @@
             </a:pPr>
             <a:r>
               <a:rPr b="1"/>
-              <a:t>Gauss-Markov Assumptions Check</a:t>
+              <a:t>Key Findings from Analysis</a:t>
             </a:r>
           </a:p>
           <a:p>
@@ -4141,11 +4565,115 @@
             </a:pPr>
             <a:r>
               <a:rPr b="1"/>
-              <a:t>1. Linearity Assessment:</a:t>
+              <a:t>Top 4 Most Influential Features:</a:t>
+            </a:r>
+          </a:p>
+          <a:p>
+            <a:pPr lvl="0" indent="-342900" marL="342900">
+              <a:buAutoNum type="arabicPeriod"/>
+            </a:pPr>
+            <a:r>
+              <a:rPr b="1"/>
+              <a:t>Number of Cylinders (cyl)</a:t>
             </a:r>
             <a:r>
               <a:rPr/>
-              <a:t> - Scatterplots reveal non-linear patterns - Residual plots show systematic curvature - Evidence of non-linear relationships with MPG</a:t>
+              <a:t> (R² = 73.24%)</a:t>
+            </a:r>
+          </a:p>
+          <a:p>
+            <a:pPr lvl="1"/>
+            <a:r>
+              <a:rPr/>
+              <a:t>Explains 73% of MPG variation.</a:t>
+            </a:r>
+          </a:p>
+          <a:p>
+            <a:pPr lvl="1"/>
+            <a:r>
+              <a:rPr/>
+              <a:t>Very strong relationship with fuel efficiency.</a:t>
+            </a:r>
+          </a:p>
+          <a:p>
+            <a:pPr lvl="0" indent="-342900" marL="342900">
+              <a:buAutoNum type="arabicPeriod"/>
+            </a:pPr>
+            <a:r>
+              <a:rPr b="1"/>
+              <a:t>Car Weight (wt)</a:t>
+            </a:r>
+            <a:r>
+              <a:rPr/>
+              <a:t> (R² = 73.16%)</a:t>
+            </a:r>
+          </a:p>
+          <a:p>
+            <a:pPr lvl="1"/>
+            <a:r>
+              <a:rPr/>
+              <a:t>Almost equally important as cylinders.</a:t>
+            </a:r>
+          </a:p>
+          <a:p>
+            <a:pPr lvl="1"/>
+            <a:r>
+              <a:rPr/>
+              <a:t>Heavier cars use more fuel.</a:t>
+            </a:r>
+          </a:p>
+          <a:p>
+            <a:pPr lvl="0" indent="-342900" marL="342900">
+              <a:buAutoNum type="arabicPeriod"/>
+            </a:pPr>
+            <a:r>
+              <a:rPr b="1"/>
+              <a:t>Engine Size (disp)</a:t>
+            </a:r>
+            <a:r>
+              <a:rPr/>
+              <a:t> (R² = 67.87%)</a:t>
+            </a:r>
+          </a:p>
+          <a:p>
+            <a:pPr lvl="1"/>
+            <a:r>
+              <a:rPr/>
+              <a:t>Larger engines typically use more fuel.</a:t>
+            </a:r>
+          </a:p>
+          <a:p>
+            <a:pPr lvl="1"/>
+            <a:r>
+              <a:rPr/>
+              <a:t>Strong predictor of MPG.</a:t>
+            </a:r>
+          </a:p>
+          <a:p>
+            <a:pPr lvl="0" indent="-342900" marL="342900">
+              <a:buAutoNum type="arabicPeriod"/>
+            </a:pPr>
+            <a:r>
+              <a:rPr b="1"/>
+              <a:t>Horsepower (hp)</a:t>
+            </a:r>
+            <a:r>
+              <a:rPr/>
+              <a:t> (R² = 56.83%)</a:t>
+            </a:r>
+          </a:p>
+          <a:p>
+            <a:pPr lvl="1"/>
+            <a:r>
+              <a:rPr/>
+              <a:t>More power means more fuel consumption.</a:t>
+            </a:r>
+          </a:p>
+          <a:p>
+            <a:pPr lvl="1"/>
+            <a:r>
+              <a:rPr/>
+              <a:t>Moderate to strong relationship.</a:t>
             </a:r>
           </a:p>
           <a:p>
@@ -4154,45 +4682,15 @@
             </a:pPr>
             <a:r>
               <a:rPr b="1"/>
-              <a:t>2. Independence Verification:</a:t>
+              <a:t>Why These Matter:</a:t>
             </a:r>
             <a:r>
               <a:rPr/>
-              <a:t> - Data points from different manufacturers - No obvious temporal dependencies - Assumed independent observations</a:t>
-            </a:r>
-          </a:p>
-        </p:txBody>
-      </p:sp>
-      <p:pic>
-        <p:nvPicPr>
-          <p:cNvPr descr="supervised_learning_files/figure-pptx/unnamed-chunk-7-1.png" id="0" name="Picture 1"/>
-          <p:cNvPicPr>
-            <a:picLocks noGrp="1" noChangeAspect="1"/>
-          </p:cNvPicPr>
-          <p:nvPr/>
-        </p:nvPicPr>
-        <p:blipFill>
-          <a:blip r:embed="rId2"/>
-          <a:stretch>
-            <a:fillRect/>
-          </a:stretch>
-        </p:blipFill>
-        <p:spPr bwMode="auto">
-          <a:xfrm>
-            <a:off x="3568700" y="1117600"/>
-            <a:ext cx="5105400" cy="2552700"/>
-          </a:xfrm>
-          <a:prstGeom prst="rect">
-            <a:avLst/>
-          </a:prstGeom>
-          <a:noFill/>
-          <a:ln w="9525">
-            <a:noFill/>
-            <a:headEnd/>
-            <a:tailEnd/>
-          </a:ln>
-        </p:spPr>
-      </p:pic>
+              <a:t> - All have strong statistical evidence (p &lt; 0.05). - Each explains more than 50% of MPG variation. - Show clear relationships with fuel efficiency.</a:t>
+            </a:r>
+          </a:p>
+        </p:txBody>
+      </p:sp>
     </p:spTree>
   </p:cSld>
 </p:sld>
@@ -4235,7 +4733,7 @@
             </a:pPr>
             <a:r>
               <a:rPr/>
-              <a:t>BLUE Analysis - Part 2</a:t>
+              <a:t>Combining Car Features</a:t>
             </a:r>
           </a:p>
         </p:txBody>
@@ -4263,7 +4761,7 @@
             </a:pPr>
             <a:r>
               <a:rPr b="1"/>
-              <a:t>Detailed Residual Analysis</a:t>
+              <a:t>Building a Better Model</a:t>
             </a:r>
           </a:p>
           <a:p>
@@ -4272,11 +4770,11 @@
             </a:pPr>
             <a:r>
               <a:rPr b="1"/>
-              <a:t>3. Homoscedasticity Check:</a:t>
+              <a:t>Initial Approach:</a:t>
             </a:r>
             <a:r>
               <a:rPr/>
-              <a:t> - Varying spread in residuals - Evidence of heteroscedasticity - Scale-Location plots show patterns</a:t>
+              <a:t> - Combined all important features together - Found some features were too closely related - Needed to simplify the model</a:t>
             </a:r>
           </a:p>
           <a:p>
@@ -4285,11 +4783,11 @@
             </a:pPr>
             <a:r>
               <a:rPr b="1"/>
-              <a:t>4. Error Distribution:</a:t>
+              <a:t>Problem Found:</a:t>
             </a:r>
             <a:r>
               <a:rPr/>
-              <a:t> - Q-Q plots show deviations - Non-normal residuals in most models - Affects inference reliability</a:t>
+              <a:t> - Engine size (disp) overlapped with other features - VIF Analysis showed redundant information: * Engine size VIF &gt; 10 (too high) * Other features had acceptable VIF values</a:t>
             </a:r>
           </a:p>
           <a:p>
@@ -4298,52 +4796,11 @@
             </a:pPr>
             <a:r>
               <a:rPr b="1"/>
-              <a:t>Statistical Evidence:</a:t>
-            </a:r>
-          </a:p>
-          <a:p>
-            <a:pPr lvl="0" indent="0">
-              <a:buNone/>
-            </a:pPr>
-            <a:r>
-              <a:rPr>
-                <a:latin typeface="Courier"/>
-              </a:rPr>
-              <a:t>Breusch-Pagan Test (Homoscedasticity):</a:t>
-            </a:r>
-          </a:p>
-          <a:p>
-            <a:pPr lvl="0" indent="0">
-              <a:buNone/>
-            </a:pPr>
-            <a:r>
-              <a:rPr>
-                <a:latin typeface="Courier"/>
-              </a:rPr>
-              <a:t>p-value: 0.0397</a:t>
-            </a:r>
-          </a:p>
-          <a:p>
-            <a:pPr lvl="0" indent="0">
-              <a:buNone/>
-            </a:pPr>
-            <a:r>
-              <a:rPr>
-                <a:latin typeface="Courier"/>
-              </a:rPr>
-              <a:t>
-Shapiro-Wilk Test (Normality):</a:t>
-            </a:r>
-          </a:p>
-          <a:p>
-            <a:pPr lvl="0" indent="0">
-              <a:buNone/>
-            </a:pPr>
-            <a:r>
-              <a:rPr>
-                <a:latin typeface="Courier"/>
-              </a:rPr>
-              <a:t>p-value: 0.8736</a:t>
+              <a:t>Final Model:</a:t>
+            </a:r>
+            <a:r>
+              <a:rPr/>
+              <a:t> - Kept three key features: 1. Car Weight (wt) 2. Horsepower (hp) 3. Transmission Type (am) - Removed redundant engine size measure. - Maintained prediction accuracy.</a:t>
             </a:r>
           </a:p>
         </p:txBody>
@@ -4380,7 +4837,12 @@
             <p:ph type="title"/>
           </p:nvPr>
         </p:nvSpPr>
-        <p:spPr/>
+        <p:spPr>
+          <a:xfrm>
+            <a:off x="457201" y="204787"/>
+            <a:ext cx="3008313" cy="871538"/>
+          </a:xfrm>
+        </p:spPr>
         <p:txBody>
           <a:bodyPr/>
           <a:lstStyle/>
@@ -4390,19 +4852,19 @@
             </a:pPr>
             <a:r>
               <a:rPr/>
-              <a:t>Multiple Regression Development</a:t>
-            </a:r>
-          </a:p>
-        </p:txBody>
-      </p:sp>
-      <p:sp>
-        <p:nvSpPr>
-          <p:cNvPr id="3" name="Content Placeholder 2"/>
-          <p:cNvSpPr>
-            <a:spLocks noGrp="1"/>
-          </p:cNvSpPr>
-          <p:nvPr>
-            <p:ph idx="1"/>
+              <a:t>LASSO Model Results</a:t>
+            </a:r>
+          </a:p>
+        </p:txBody>
+      </p:sp>
+      <p:sp>
+        <p:nvSpPr>
+          <p:cNvPr id="4" name="Text Placeholder 3"/>
+          <p:cNvSpPr>
+            <a:spLocks noGrp="1"/>
+          </p:cNvSpPr>
+          <p:nvPr>
+            <p:ph idx="2" sz="half" type="body"/>
           </p:nvPr>
         </p:nvSpPr>
         <p:spPr/>
@@ -4418,7 +4880,7 @@
             </a:pPr>
             <a:r>
               <a:rPr b="1"/>
-              <a:t>Building the Comprehensive Model</a:t>
+              <a:t>Smart Feature Selection</a:t>
             </a:r>
           </a:p>
           <a:p>
@@ -4427,22 +4889,11 @@
             </a:pPr>
             <a:r>
               <a:rPr b="1"/>
-              <a:t>1. Variable Selection Process:</a:t>
+              <a:t>What LASSO Does:</a:t>
             </a:r>
             <a:r>
               <a:rPr/>
-              <a:t> - Started with significant predictors (p &lt; 0.05):</a:t>
-            </a:r>
-          </a:p>
-          <a:p>
-            <a:pPr lvl="0" indent="0">
-              <a:buNone/>
-            </a:pPr>
-            <a:r>
-              <a:rPr>
-                <a:latin typeface="Courier"/>
-              </a:rPr>
-              <a:t>cyl, wt, disp, hp, drat, am, vs, carb, qsec</a:t>
+              <a:t> - Automatically picks the most important car features - Removes less important features - Helps avoid overcomplicating the model</a:t>
             </a:r>
           </a:p>
           <a:p>
@@ -4451,40 +4902,274 @@
             </a:pPr>
             <a:r>
               <a:rPr b="1"/>
-              <a:t>2. Initial Multiple Regression:</a:t>
-            </a:r>
-          </a:p>
-          <a:p>
-            <a:pPr lvl="0" indent="0">
-              <a:buNone/>
-            </a:pPr>
-            <a:r>
-              <a:rPr>
-                <a:latin typeface="Courier"/>
-              </a:rPr>
-              <a:t>R-squared: 0.875 </a:t>
-            </a:r>
-          </a:p>
-          <a:p>
-            <a:pPr lvl="0" indent="0">
-              <a:buNone/>
-            </a:pPr>
-            <a:r>
-              <a:rPr>
-                <a:latin typeface="Courier"/>
-              </a:rPr>
-              <a:t>Adjusted R-squared: 0.7625 </a:t>
-            </a:r>
-          </a:p>
-          <a:p>
-            <a:pPr lvl="0" indent="0">
-              <a:buNone/>
-            </a:pPr>
-            <a:r>
-              <a:rPr>
-                <a:latin typeface="Courier"/>
-              </a:rPr>
-              <a:t>F-statistic: 7.78  on 9 and 10 DF</a:t>
+              <a:t>Key Results:</a:t>
+            </a:r>
+          </a:p>
+          <a:p>
+            <a:pPr lvl="0" indent="-342900" marL="342900">
+              <a:buAutoNum type="arabicPeriod"/>
+            </a:pPr>
+            <a:r>
+              <a:rPr/>
+              <a:t>Most Important Features Selected:</a:t>
+            </a:r>
+          </a:p>
+          <a:p>
+            <a:pPr lvl="1"/>
+            <a:r>
+              <a:rPr/>
+              <a:t>Car Weight (wt)</a:t>
+            </a:r>
+          </a:p>
+          <a:p>
+            <a:pPr lvl="1"/>
+            <a:r>
+              <a:rPr/>
+              <a:t>Horsepower (hp)</a:t>
+            </a:r>
+          </a:p>
+          <a:p>
+            <a:pPr lvl="1"/>
+            <a:r>
+              <a:rPr/>
+              <a:t>Transmission Type (Manual/Auto)</a:t>
+            </a:r>
+          </a:p>
+          <a:p>
+            <a:pPr lvl="0" indent="-342900" marL="342900">
+              <a:buAutoNum type="arabicPeriod"/>
+            </a:pPr>
+            <a:r>
+              <a:rPr/>
+              <a:t>Model Performance:</a:t>
+            </a:r>
+          </a:p>
+          <a:p>
+            <a:pPr lvl="1"/>
+            <a:r>
+              <a:rPr/>
+              <a:t>Training RMSE: Shows typical prediction error</a:t>
+            </a:r>
+          </a:p>
+          <a:p>
+            <a:pPr lvl="1"/>
+            <a:r>
+              <a:rPr/>
+              <a:t>Testing RMSE: Confirms model reliability</a:t>
+            </a:r>
+          </a:p>
+          <a:p>
+            <a:pPr lvl="1"/>
+            <a:r>
+              <a:rPr/>
+              <a:t>Similar performance to standard regression</a:t>
+            </a:r>
+          </a:p>
+          <a:p>
+            <a:pPr lvl="0" indent="0" marL="0">
+              <a:buNone/>
+            </a:pPr>
+            <a:r>
+              <a:rPr b="1"/>
+              <a:t>Why This Matters:</a:t>
+            </a:r>
+            <a:r>
+              <a:rPr/>
+              <a:t> - Confirms our earlier findings. - Simpler model, similar accuracy. - More reliable predictions.</a:t>
+            </a:r>
+          </a:p>
+          <a:p>
+            <a:pPr lvl="0" indent="0" marL="0">
+              <a:spcBef>
+                <a:spcPts val="3000"/>
+              </a:spcBef>
+              <a:buNone/>
+            </a:pPr>
+            <a:r>
+              <a:rPr b="1"/>
+              <a:t>Visualizing LASSO: Finding the Best Balance</a:t>
+            </a:r>
+          </a:p>
+        </p:txBody>
+      </p:sp>
+      <p:pic>
+        <p:nvPicPr>
+          <p:cNvPr descr="supervised_learning_files/figure-pptx/unnamed-chunk-7-1.png" id="0" name="Picture 1"/>
+          <p:cNvPicPr>
+            <a:picLocks noGrp="1" noChangeAspect="1"/>
+          </p:cNvPicPr>
+          <p:nvPr/>
+        </p:nvPicPr>
+        <p:blipFill>
+          <a:blip r:embed="rId2"/>
+          <a:stretch>
+            <a:fillRect/>
+          </a:stretch>
+        </p:blipFill>
+        <p:spPr bwMode="auto">
+          <a:xfrm>
+            <a:off x="3568700" y="863600"/>
+            <a:ext cx="5105400" cy="2552700"/>
+          </a:xfrm>
+          <a:prstGeom prst="rect">
+            <a:avLst/>
+          </a:prstGeom>
+          <a:noFill/>
+          <a:ln w="9525">
+            <a:noFill/>
+            <a:headEnd/>
+            <a:tailEnd/>
+          </a:ln>
+        </p:spPr>
+      </p:pic>
+      <p:sp>
+        <p:nvSpPr>
+          <p:cNvPr id="1" name="TextBox 3"/>
+          <p:cNvSpPr txBox="1"/>
+          <p:nvPr/>
+        </p:nvSpPr>
+        <p:spPr>
+          <a:xfrm>
+            <a:off x="3568700" y="4076700"/>
+            <a:ext cx="5105400" cy="508000"/>
+          </a:xfrm>
+          <a:prstGeom prst="rect">
+            <a:avLst/>
+          </a:prstGeom>
+          <a:noFill/>
+        </p:spPr>
+        <p:txBody>
+          <a:bodyPr/>
+          <a:lstStyle/>
+          <a:p>
+            <a:pPr lvl="0" indent="0" marL="0" algn="ctr">
+              <a:buNone/>
+            </a:pPr>
+            <a:r>
+              <a:rPr/>
+              <a:t>LASSO Cross-Validation: This chart helps LASSO find the best balance. It’s like tuning a radio to get the clearest signal – we’re finding the ‘sweet spot’ for our model. The dotted line shows the best point.</a:t>
+            </a:r>
+          </a:p>
+        </p:txBody>
+      </p:sp>
+      <p:sp>
+        <p:nvSpPr>
+          <p:cNvPr id="3" name="Content Placeholder 2"/>
+          <p:cNvSpPr>
+            <a:spLocks noGrp="1"/>
+          </p:cNvSpPr>
+          <p:nvPr>
+            <p:ph idx="1"/>
+          </p:nvPr>
+        </p:nvSpPr>
+        <p:spPr/>
+        <p:txBody>
+          <a:bodyPr/>
+          <a:lstStyle/>
+          <a:p>
+            <a:pPr lvl="0" indent="0" marL="0">
+              <a:buNone/>
+            </a:pPr>
+            <a:r>
+              <a:rPr/>
+              <a:t>This plot shows how the model’s error changes as LASSO adjusts its “strictness” (lambda). The vertical dotted lines indicate optimal lambda values, helping us choose the best model.</a:t>
+            </a:r>
+          </a:p>
+          <a:p>
+            <a:pPr lvl="0" indent="0" marL="0">
+              <a:spcBef>
+                <a:spcPts val="3000"/>
+              </a:spcBef>
+              <a:buNone/>
+            </a:pPr>
+            <a:r>
+              <a:rPr b="1"/>
+              <a:t>Visualizing LASSO: Which Features Matter Most?</a:t>
+            </a:r>
+          </a:p>
+        </p:txBody>
+      </p:sp>
+      <p:pic>
+        <p:nvPicPr>
+          <p:cNvPr descr="supervised_learning_files/figure-pptx/unnamed-chunk-8-1.png" id="0" name="Picture 1"/>
+          <p:cNvPicPr>
+            <a:picLocks noGrp="1" noChangeAspect="1"/>
+          </p:cNvPicPr>
+          <p:nvPr/>
+        </p:nvPicPr>
+        <p:blipFill>
+          <a:blip r:embed="rId3"/>
+          <a:stretch>
+            <a:fillRect/>
+          </a:stretch>
+        </p:blipFill>
+        <p:spPr bwMode="auto">
+          <a:xfrm>
+            <a:off x="3568700" y="863600"/>
+            <a:ext cx="5105400" cy="2552700"/>
+          </a:xfrm>
+          <a:prstGeom prst="rect">
+            <a:avLst/>
+          </a:prstGeom>
+          <a:noFill/>
+          <a:ln w="9525">
+            <a:noFill/>
+            <a:headEnd/>
+            <a:tailEnd/>
+          </a:ln>
+        </p:spPr>
+      </p:pic>
+      <p:sp>
+        <p:nvSpPr>
+          <p:cNvPr id="1" name="TextBox 3"/>
+          <p:cNvSpPr txBox="1"/>
+          <p:nvPr/>
+        </p:nvSpPr>
+        <p:spPr>
+          <a:xfrm>
+            <a:off x="3568700" y="4076700"/>
+            <a:ext cx="5105400" cy="508000"/>
+          </a:xfrm>
+          <a:prstGeom prst="rect">
+            <a:avLst/>
+          </a:prstGeom>
+          <a:noFill/>
+        </p:spPr>
+        <p:txBody>
+          <a:bodyPr/>
+          <a:lstStyle/>
+          <a:p>
+            <a:pPr lvl="0" indent="0" marL="0" algn="ctr">
+              <a:buNone/>
+            </a:pPr>
+            <a:r>
+              <a:rPr/>
+              <a:t>LASSO Coefficient Path: Imagine LASSO as a manager deciding which players (features) are most valuable. This plot shows how, as LASSO gets stricter, it keeps only the star players and lets others go. Lines that stay high are important; lines that drop to zero are removed.</a:t>
+            </a:r>
+          </a:p>
+        </p:txBody>
+      </p:sp>
+      <p:sp>
+        <p:nvSpPr>
+          <p:cNvPr id="3" name="Content Placeholder 2"/>
+          <p:cNvSpPr>
+            <a:spLocks noGrp="1"/>
+          </p:cNvSpPr>
+          <p:nvPr>
+            <p:ph idx="1"/>
+          </p:nvPr>
+        </p:nvSpPr>
+        <p:spPr/>
+        <p:txBody>
+          <a:bodyPr/>
+          <a:lstStyle/>
+          <a:p>
+            <a:pPr lvl="0" indent="0" marL="0">
+              <a:buNone/>
+            </a:pPr>
+            <a:r>
+              <a:rPr/>
+              <a:t>This chart shows the “MVPs” (Most Valuable Predictors) selected by LASSO. Bigger values (further from zero) mean more impact on fuel efficiency.</a:t>
             </a:r>
           </a:p>
         </p:txBody>
@@ -4531,7 +5216,7 @@
             </a:pPr>
             <a:r>
               <a:rPr/>
-              <a:t>Multicollinearity Analysis</a:t>
+              <a:t>Model Performance Comparison</a:t>
             </a:r>
           </a:p>
         </p:txBody>
@@ -4559,16 +5244,7 @@
             </a:pPr>
             <a:r>
               <a:rPr b="1"/>
-              <a:t>VIF Assessment and Model Refinement</a:t>
-            </a:r>
-          </a:p>
-          <a:p>
-            <a:pPr lvl="0" indent="0" marL="0">
-              <a:buNone/>
-            </a:pPr>
-            <a:r>
-              <a:rPr b="1"/>
-              <a:t>Initial VIF Values:</a:t>
+              <a:t>Comprehensive Metrics Analysis</a:t>
             </a:r>
           </a:p>
           <a:p>
@@ -4579,41 +5255,9 @@
               <a:rPr>
                 <a:latin typeface="Courier"/>
               </a:rPr>
-              <a:t>  cyl    wt  disp    hp  drat    am    vs  carb  qsec 
-15.46 14.30 30.66 21.52  4.06  7.05  9.40 11.71 14.52 </a:t>
-            </a:r>
-          </a:p>
-          <a:p>
-            <a:pPr lvl="0" indent="0" marL="0">
-              <a:buNone/>
-            </a:pPr>
-            <a:r>
-              <a:rPr b="1"/>
-              <a:t>Variable Elimination Process:</a:t>
-            </a:r>
-            <a:r>
-              <a:rPr/>
-              <a:t> 1. Remove highest VIF variable iteratively 2. Recalculate VIF after each removal 3. Continue until all VIF &lt; 10</a:t>
-            </a:r>
-          </a:p>
-          <a:p>
-            <a:pPr lvl="0" indent="0" marL="0">
-              <a:buNone/>
-            </a:pPr>
-            <a:r>
-              <a:rPr b="1"/>
-              <a:t>Final Model Variables:</a:t>
-            </a:r>
-          </a:p>
-          <a:p>
-            <a:pPr lvl="0" indent="0">
-              <a:buNone/>
-            </a:pPr>
-            <a:r>
-              <a:rPr>
-                <a:latin typeface="Courier"/>
-              </a:rPr>
-              <a:t>wt, hp, am</a:t>
+              <a:t>                     RMSE   MAE    R2
+Multiple Regression 2.663 2.214 0.807
+LASSO Regression    2.369 1.882 0.847</a:t>
             </a:r>
           </a:p>
         </p:txBody>
@@ -4650,12 +5294,7 @@
             <p:ph type="title"/>
           </p:nvPr>
         </p:nvSpPr>
-        <p:spPr>
-          <a:xfrm>
-            <a:off x="457201" y="204787"/>
-            <a:ext cx="3008313" cy="871538"/>
-          </a:xfrm>
-        </p:spPr>
+        <p:spPr/>
         <p:txBody>
           <a:bodyPr/>
           <a:lstStyle/>
@@ -4665,19 +5304,19 @@
             </a:pPr>
             <a:r>
               <a:rPr/>
-              <a:t>LASSO Regression Analysis</a:t>
-            </a:r>
-          </a:p>
-        </p:txBody>
-      </p:sp>
-      <p:sp>
-        <p:nvSpPr>
-          <p:cNvPr id="4" name="Text Placeholder 3"/>
-          <p:cNvSpPr>
-            <a:spLocks noGrp="1"/>
-          </p:cNvSpPr>
-          <p:nvPr>
-            <p:ph idx="2" sz="half" type="body"/>
+              <a:t>Predicting Fuel Efficiency</a:t>
+            </a:r>
+          </a:p>
+        </p:txBody>
+      </p:sp>
+      <p:sp>
+        <p:nvSpPr>
+          <p:cNvPr id="3" name="Content Placeholder 2"/>
+          <p:cNvSpPr>
+            <a:spLocks noGrp="1"/>
+          </p:cNvSpPr>
+          <p:nvPr>
+            <p:ph idx="1"/>
           </p:nvPr>
         </p:nvSpPr>
         <p:spPr/>
@@ -4693,7 +5332,7 @@
             </a:pPr>
             <a:r>
               <a:rPr b="1"/>
-              <a:t>Advanced Variable Selection</a:t>
+              <a:t>Example: 6000 lbs Car</a:t>
             </a:r>
           </a:p>
           <a:p>
@@ -4702,45 +5341,28 @@
             </a:pPr>
             <a:r>
               <a:rPr b="1"/>
-              <a:t>LASSO Implementation:</a:t>
+              <a:t>Prediction:</a:t>
             </a:r>
             <a:r>
               <a:rPr/>
-              <a:t> 1. Cross-validation for lambda selection 2. Automatic variable selection 3. Coefficient shrinkage effect</a:t>
-            </a:r>
-          </a:p>
-        </p:txBody>
-      </p:sp>
-      <p:pic>
-        <p:nvPicPr>
-          <p:cNvPr descr="supervised_learning_files/figure-pptx/unnamed-chunk-14-1.png" id="0" name="Picture 1"/>
-          <p:cNvPicPr>
-            <a:picLocks noGrp="1" noChangeAspect="1"/>
-          </p:cNvPicPr>
-          <p:nvPr/>
-        </p:nvPicPr>
-        <p:blipFill>
-          <a:blip r:embed="rId2"/>
-          <a:stretch>
-            <a:fillRect/>
-          </a:stretch>
-        </p:blipFill>
-        <p:spPr bwMode="auto">
-          <a:xfrm>
-            <a:off x="3568700" y="1117600"/>
-            <a:ext cx="5105400" cy="2552700"/>
-          </a:xfrm>
-          <a:prstGeom prst="rect">
-            <a:avLst/>
-          </a:prstGeom>
-          <a:noFill/>
-          <a:ln w="9525">
-            <a:noFill/>
-            <a:headEnd/>
-            <a:tailEnd/>
-          </a:ln>
-        </p:spPr>
-      </p:pic>
+              <a:t> - For a 6000 lbs car, predicted MPG is 13.41 - 95% sure it’s between 0.93 and 25.88 MPG</a:t>
+            </a:r>
+          </a:p>
+          <a:p>
+            <a:pPr lvl="0" indent="0" marL="0">
+              <a:buNone/>
+            </a:pPr>
+            <a:r>
+              <a:rPr b="1"/>
+              <a:t>Important Note:</a:t>
+            </a:r>
+            <a:r>
+              <a:rPr/>
+              <a:t> - This is an estimate for a very heavy car - Our data doesn’t include cars this heavy - Predictions outside data range are less reliable</a:t>
+            </a:r>
+          </a:p>
+        </p:txBody>
+      </p:sp>
     </p:spTree>
   </p:cSld>
 </p:sld>

</xml_diff>

<commit_message>
Add presentation files and update QMD format for Decision Tree and Random Forest comparison
- Added new PowerPoint presentation file `presentation_2.pptx`.
- Changed the format of `presentation_2.qmd` from Reveal.js to PPTX.
- Updated response variable `y` to use `as.factor()` for better clarity.
</commit_message>
<xml_diff>
--- a/presentation_1/supervised_learning.pptx
+++ b/presentation_1/supervised_learning.pptx
@@ -16,6 +16,8 @@
     <p:sldId id="264" r:id="rId10"/>
     <p:sldId id="265" r:id="rId11"/>
     <p:sldId id="266" r:id="rId12"/>
+    <p:sldId id="267" r:id="rId13"/>
+    <p:sldId id="268" r:id="rId14"/>
   </p:sldIdLst>
   <p:sldSz cx="9144000" cy="5143500" type="screen16x9"/>
   <p:notesSz cx="6858000" cy="9144000"/>
@@ -3208,7 +3210,7 @@
             </a:pPr>
             <a:r>
               <a:rPr/>
-              <a:t>Key Takeaways &amp; Next Steps</a:t>
+              <a:t>Model Performance Comparison</a:t>
             </a:r>
           </a:p>
         </p:txBody>
@@ -3236,73 +3238,20 @@
             </a:pPr>
             <a:r>
               <a:rPr b="1"/>
-              <a:t>Main Findings:</a:t>
-            </a:r>
-          </a:p>
-          <a:p>
-            <a:pPr lvl="0" indent="-342900" marL="342900">
-              <a:buAutoNum type="arabicPeriod"/>
+              <a:t>Comprehensive Metrics Analysis</a:t>
+            </a:r>
+          </a:p>
+          <a:p>
+            <a:pPr lvl="0" indent="0">
+              <a:buNone/>
             </a:pPr>
             <a:r>
-              <a:rPr/>
-              <a:t>Car Weight, Horsepower, and Transmission are key for MPG</a:t>
-            </a:r>
-          </a:p>
-          <a:p>
-            <a:pPr lvl="0" indent="-342900" marL="342900">
-              <a:buAutoNum type="arabicPeriod"/>
-            </a:pPr>
-            <a:r>
-              <a:rPr/>
-              <a:t>LASSO helps simplify models without losing accuracy</a:t>
-            </a:r>
-          </a:p>
-          <a:p>
-            <a:pPr lvl="0" indent="-342900" marL="342900">
-              <a:buAutoNum type="arabicPeriod"/>
-            </a:pPr>
-            <a:r>
-              <a:rPr/>
-              <a:t>Predictions are useful but have limits</a:t>
-            </a:r>
-          </a:p>
-          <a:p>
-            <a:pPr lvl="0" indent="0" marL="0">
-              <a:spcBef>
-                <a:spcPts val="3000"/>
-              </a:spcBef>
-              <a:buNone/>
-            </a:pPr>
-            <a:r>
-              <a:rPr b="1"/>
-              <a:t>Recommendations:</a:t>
-            </a:r>
-          </a:p>
-          <a:p>
-            <a:pPr lvl="0" indent="-342900" marL="342900">
-              <a:buAutoNum type="arabicPeriod"/>
-            </a:pPr>
-            <a:r>
-              <a:rPr/>
-              <a:t>Use modern car data for better insights</a:t>
-            </a:r>
-          </a:p>
-          <a:p>
-            <a:pPr lvl="0" indent="-342900" marL="342900">
-              <a:buAutoNum type="arabicPeriod"/>
-            </a:pPr>
-            <a:r>
-              <a:rPr/>
-              <a:t>Explore more advanced modeling techniques</a:t>
-            </a:r>
-          </a:p>
-          <a:p>
-            <a:pPr lvl="0" indent="-342900" marL="342900">
-              <a:buAutoNum type="arabicPeriod"/>
-            </a:pPr>
-            <a:r>
-              <a:rPr/>
-              <a:t>Always be cautious with predictions outside data range</a:t>
+              <a:rPr>
+                <a:latin typeface="Courier"/>
+              </a:rPr>
+              <a:t>                     RMSE   MAE    R2
+Multiple Regression 2.663 2.214 0.807
+LASSO Regression    2.369 1.882 0.847</a:t>
             </a:r>
           </a:p>
         </p:txBody>
@@ -3313,6 +3262,248 @@
 </file>
 
 <file path=ppt/slides/slide11.xml><?xml version="1.0" encoding="utf-8"?>
+<p:sld xmlns:a="http://schemas.openxmlformats.org/drawingml/2006/main" xmlns:r="http://schemas.openxmlformats.org/officeDocument/2006/relationships" xmlns:p="http://schemas.openxmlformats.org/presentationml/2006/main">
+  <p:cSld>
+    <p:spTree>
+      <p:nvGrpSpPr>
+        <p:cNvPr id="1" name=""/>
+        <p:cNvGrpSpPr/>
+        <p:nvPr/>
+      </p:nvGrpSpPr>
+      <p:grpSpPr>
+        <a:xfrm>
+          <a:off x="0" y="0"/>
+          <a:ext cx="0" cy="0"/>
+          <a:chOff x="0" y="0"/>
+          <a:chExt cx="0" cy="0"/>
+        </a:xfrm>
+      </p:grpSpPr>
+      <p:sp>
+        <p:nvSpPr>
+          <p:cNvPr id="2" name="Title 1"/>
+          <p:cNvSpPr>
+            <a:spLocks noGrp="1"/>
+          </p:cNvSpPr>
+          <p:nvPr>
+            <p:ph type="title"/>
+          </p:nvPr>
+        </p:nvSpPr>
+        <p:spPr/>
+        <p:txBody>
+          <a:bodyPr/>
+          <a:lstStyle/>
+          <a:p>
+            <a:pPr lvl="0" indent="0" marL="0">
+              <a:buNone/>
+            </a:pPr>
+            <a:r>
+              <a:rPr/>
+              <a:t>Predicting Fuel Efficiency</a:t>
+            </a:r>
+          </a:p>
+        </p:txBody>
+      </p:sp>
+      <p:sp>
+        <p:nvSpPr>
+          <p:cNvPr id="3" name="Content Placeholder 2"/>
+          <p:cNvSpPr>
+            <a:spLocks noGrp="1"/>
+          </p:cNvSpPr>
+          <p:nvPr>
+            <p:ph idx="1"/>
+          </p:nvPr>
+        </p:nvSpPr>
+        <p:spPr/>
+        <p:txBody>
+          <a:bodyPr/>
+          <a:lstStyle/>
+          <a:p>
+            <a:pPr lvl="0" indent="0" marL="0">
+              <a:spcBef>
+                <a:spcPts val="3000"/>
+              </a:spcBef>
+              <a:buNone/>
+            </a:pPr>
+            <a:r>
+              <a:rPr b="1"/>
+              <a:t>Example: 6000 lbs Car</a:t>
+            </a:r>
+          </a:p>
+          <a:p>
+            <a:pPr lvl="0" indent="0" marL="0">
+              <a:buNone/>
+            </a:pPr>
+            <a:r>
+              <a:rPr b="1"/>
+              <a:t>Prediction:</a:t>
+            </a:r>
+            <a:r>
+              <a:rPr/>
+              <a:t> - For a 6000 lbs car, predicted MPG is 13.41 - 95% sure it’s between 0.93 and 25.88 MPG</a:t>
+            </a:r>
+          </a:p>
+          <a:p>
+            <a:pPr lvl="0" indent="0" marL="0">
+              <a:buNone/>
+            </a:pPr>
+            <a:r>
+              <a:rPr b="1"/>
+              <a:t>Important Note:</a:t>
+            </a:r>
+            <a:r>
+              <a:rPr/>
+              <a:t> - This is an estimate for a very heavy car - Our data doesn’t include cars this heavy - Predictions outside data range are less reliable</a:t>
+            </a:r>
+          </a:p>
+        </p:txBody>
+      </p:sp>
+    </p:spTree>
+  </p:cSld>
+</p:sld>
+</file>
+
+<file path=ppt/slides/slide12.xml><?xml version="1.0" encoding="utf-8"?>
+<p:sld xmlns:a="http://schemas.openxmlformats.org/drawingml/2006/main" xmlns:r="http://schemas.openxmlformats.org/officeDocument/2006/relationships" xmlns:p="http://schemas.openxmlformats.org/presentationml/2006/main">
+  <p:cSld>
+    <p:spTree>
+      <p:nvGrpSpPr>
+        <p:cNvPr id="1" name=""/>
+        <p:cNvGrpSpPr/>
+        <p:nvPr/>
+      </p:nvGrpSpPr>
+      <p:grpSpPr>
+        <a:xfrm>
+          <a:off x="0" y="0"/>
+          <a:ext cx="0" cy="0"/>
+          <a:chOff x="0" y="0"/>
+          <a:chExt cx="0" cy="0"/>
+        </a:xfrm>
+      </p:grpSpPr>
+      <p:sp>
+        <p:nvSpPr>
+          <p:cNvPr id="2" name="Title 1"/>
+          <p:cNvSpPr>
+            <a:spLocks noGrp="1"/>
+          </p:cNvSpPr>
+          <p:nvPr>
+            <p:ph type="title"/>
+          </p:nvPr>
+        </p:nvSpPr>
+        <p:spPr/>
+        <p:txBody>
+          <a:bodyPr/>
+          <a:lstStyle/>
+          <a:p>
+            <a:pPr lvl="0" indent="0" marL="0">
+              <a:buNone/>
+            </a:pPr>
+            <a:r>
+              <a:rPr/>
+              <a:t>Key Takeaways &amp; Next Steps</a:t>
+            </a:r>
+          </a:p>
+        </p:txBody>
+      </p:sp>
+      <p:sp>
+        <p:nvSpPr>
+          <p:cNvPr id="3" name="Content Placeholder 2"/>
+          <p:cNvSpPr>
+            <a:spLocks noGrp="1"/>
+          </p:cNvSpPr>
+          <p:nvPr>
+            <p:ph idx="1"/>
+          </p:nvPr>
+        </p:nvSpPr>
+        <p:spPr/>
+        <p:txBody>
+          <a:bodyPr/>
+          <a:lstStyle/>
+          <a:p>
+            <a:pPr lvl="0" indent="0" marL="0">
+              <a:spcBef>
+                <a:spcPts val="3000"/>
+              </a:spcBef>
+              <a:buNone/>
+            </a:pPr>
+            <a:r>
+              <a:rPr b="1"/>
+              <a:t>Main Findings:</a:t>
+            </a:r>
+          </a:p>
+          <a:p>
+            <a:pPr lvl="0" indent="-342900" marL="342900">
+              <a:buAutoNum type="arabicPeriod"/>
+            </a:pPr>
+            <a:r>
+              <a:rPr/>
+              <a:t>Car Weight, Horsepower, and Transmission are key for MPG</a:t>
+            </a:r>
+          </a:p>
+          <a:p>
+            <a:pPr lvl="0" indent="-342900" marL="342900">
+              <a:buAutoNum type="arabicPeriod"/>
+            </a:pPr>
+            <a:r>
+              <a:rPr/>
+              <a:t>LASSO helps simplify models without losing accuracy</a:t>
+            </a:r>
+          </a:p>
+          <a:p>
+            <a:pPr lvl="0" indent="-342900" marL="342900">
+              <a:buAutoNum type="arabicPeriod"/>
+            </a:pPr>
+            <a:r>
+              <a:rPr/>
+              <a:t>Predictions are useful but have limits</a:t>
+            </a:r>
+          </a:p>
+          <a:p>
+            <a:pPr lvl="0" indent="0" marL="0">
+              <a:spcBef>
+                <a:spcPts val="3000"/>
+              </a:spcBef>
+              <a:buNone/>
+            </a:pPr>
+            <a:r>
+              <a:rPr b="1"/>
+              <a:t>Recommendations:</a:t>
+            </a:r>
+          </a:p>
+          <a:p>
+            <a:pPr lvl="0" indent="-342900" marL="342900">
+              <a:buAutoNum type="arabicPeriod"/>
+            </a:pPr>
+            <a:r>
+              <a:rPr/>
+              <a:t>Use modern car data for better insights</a:t>
+            </a:r>
+          </a:p>
+          <a:p>
+            <a:pPr lvl="0" indent="-342900" marL="342900">
+              <a:buAutoNum type="arabicPeriod"/>
+            </a:pPr>
+            <a:r>
+              <a:rPr/>
+              <a:t>Explore more advanced modeling techniques</a:t>
+            </a:r>
+          </a:p>
+          <a:p>
+            <a:pPr lvl="0" indent="-342900" marL="342900">
+              <a:buAutoNum type="arabicPeriod"/>
+            </a:pPr>
+            <a:r>
+              <a:rPr/>
+              <a:t>Always be cautious with predictions outside data range</a:t>
+            </a:r>
+          </a:p>
+        </p:txBody>
+      </p:sp>
+    </p:spTree>
+  </p:cSld>
+</p:sld>
+</file>
+
+<file path=ppt/slides/slide13.xml><?xml version="1.0" encoding="utf-8"?>
 <p:sld xmlns:a="http://schemas.openxmlformats.org/drawingml/2006/main" xmlns:r="http://schemas.openxmlformats.org/officeDocument/2006/relationships" xmlns:p="http://schemas.openxmlformats.org/presentationml/2006/main">
   <p:cSld>
     <p:spTree>
@@ -4376,6 +4567,104 @@
             <p:ph type="title"/>
           </p:nvPr>
         </p:nvSpPr>
+        <p:spPr/>
+        <p:txBody>
+          <a:bodyPr/>
+          <a:lstStyle/>
+          <a:p>
+            <a:pPr lvl="0" indent="0" marL="0">
+              <a:buNone/>
+            </a:pPr>
+            <a:r>
+              <a:rPr/>
+              <a:t>Simple Linear Regression Analysis</a:t>
+            </a:r>
+          </a:p>
+        </p:txBody>
+      </p:sp>
+      <p:sp>
+        <p:nvSpPr>
+          <p:cNvPr id="3" name="Content Placeholder 2"/>
+          <p:cNvSpPr>
+            <a:spLocks noGrp="1"/>
+          </p:cNvSpPr>
+          <p:nvPr>
+            <p:ph idx="1"/>
+          </p:nvPr>
+        </p:nvSpPr>
+        <p:spPr/>
+        <p:txBody>
+          <a:bodyPr/>
+          <a:lstStyle/>
+          <a:p>
+            <a:pPr lvl="0" indent="0" marL="0">
+              <a:spcBef>
+                <a:spcPts val="3000"/>
+              </a:spcBef>
+              <a:buNone/>
+            </a:pPr>
+            <a:r>
+              <a:rPr b="1"/>
+              <a:t>Individual Variable Performance</a:t>
+            </a:r>
+          </a:p>
+          <a:p>
+            <a:pPr lvl="0" indent="0" marL="0">
+              <a:buNone/>
+            </a:pPr>
+            <a:r>
+              <a:rPr b="1"/>
+              <a:t>Top Performing Variables (R² values):</a:t>
+            </a:r>
+          </a:p>
+          <a:p>
+            <a:pPr lvl="0" indent="0">
+              <a:buNone/>
+            </a:pPr>
+            <a:r>
+              <a:rPr>
+                <a:latin typeface="Courier"/>
+              </a:rPr>
+              <a:t>cyl: 73.2% (p = 0.0000014968)
+wt: 73.2% (p = 0.0000015375)
+disp: 67.9% (p = 0.0000080226)
+hp: 56.8% (p = 0.0001238260)</a:t>
+            </a:r>
+          </a:p>
+        </p:txBody>
+      </p:sp>
+    </p:spTree>
+  </p:cSld>
+</p:sld>
+</file>
+
+<file path=ppt/slides/slide5.xml><?xml version="1.0" encoding="utf-8"?>
+<p:sld xmlns:a="http://schemas.openxmlformats.org/drawingml/2006/main" xmlns:r="http://schemas.openxmlformats.org/officeDocument/2006/relationships" xmlns:p="http://schemas.openxmlformats.org/presentationml/2006/main">
+  <p:cSld>
+    <p:spTree>
+      <p:nvGrpSpPr>
+        <p:cNvPr id="1" name=""/>
+        <p:cNvGrpSpPr/>
+        <p:nvPr/>
+      </p:nvGrpSpPr>
+      <p:grpSpPr>
+        <a:xfrm>
+          <a:off x="0" y="0"/>
+          <a:ext cx="0" cy="0"/>
+          <a:chOff x="0" y="0"/>
+          <a:chExt cx="0" cy="0"/>
+        </a:xfrm>
+      </p:grpSpPr>
+      <p:sp>
+        <p:nvSpPr>
+          <p:cNvPr id="2" name="Title 1"/>
+          <p:cNvSpPr>
+            <a:spLocks noGrp="1"/>
+          </p:cNvSpPr>
+          <p:nvPr>
+            <p:ph type="title"/>
+          </p:nvPr>
+        </p:nvSpPr>
         <p:spPr>
           <a:xfrm>
             <a:off x="457201" y="204787"/>
@@ -4391,7 +4680,7 @@
             </a:pPr>
             <a:r>
               <a:rPr/>
-              <a:t>Simple Linear Regression Analysis</a:t>
+              <a:t>BLUE Test Results</a:t>
             </a:r>
           </a:p>
         </p:txBody>
@@ -4419,30 +4708,1108 @@
             </a:pPr>
             <a:r>
               <a:rPr b="1"/>
-              <a:t>Individual Variable Performance</a:t>
-            </a:r>
-          </a:p>
+              <a:t>Model Assessment Summary</a:t>
+            </a:r>
+          </a:p>
+        </p:txBody>
+      </p:sp>
+      <p:graphicFrame>
+        <p:nvGraphicFramePr>
+          <p:cNvPr id="6" name="Content Placeholder 5"/>
+          <p:cNvGraphicFramePr>
+            <a:graphicFrameLocks noGrp="1"/>
+          </p:cNvGraphicFramePr>
+          <p:nvPr>
+            <p:ph idx="1"/>
+          </p:nvPr>
+        </p:nvGraphicFramePr>
+        <p:xfrm>
+          <a:off x="3568700" y="203200"/>
+          <a:ext cx="5105400" cy="4381500"/>
+        </p:xfrm>
+        <a:graphic>
+          <a:graphicData uri="http://schemas.openxmlformats.org/drawingml/2006/table">
+            <a:tbl>
+              <a:tblPr firstRow="1" bandRow="1">
+                <a:tableStyleId>{5C22544A-7EE6-4342-B048-85BDC9FD1C3A}</a:tableStyleId>
+              </a:tblPr>
+              <a:tblGrid>
+                <a:gridCol w="647700"/>
+                <a:gridCol w="863600"/>
+                <a:gridCol w="1003300"/>
+                <a:gridCol w="1155700"/>
+                <a:gridCol w="1003300"/>
+                <a:gridCol w="431800"/>
+              </a:tblGrid>
+              <a:tr h="0">
+                <a:tc>
+                  <a:txBody>
+                    <a:bodyPr/>
+                    <a:lstStyle/>
+                    <a:p>
+                      <a:pPr lvl="0" indent="0" marL="0" algn="l">
+                        <a:buNone/>
+                      </a:pPr>
+                      <a:r>
+                        <a:rPr/>
+                        <a:t>Variable</a:t>
+                      </a:r>
+                    </a:p>
+                  </a:txBody>
+                  <a:tcPr/>
+                </a:tc>
+                <a:tc>
+                  <a:txBody>
+                    <a:bodyPr/>
+                    <a:lstStyle/>
+                    <a:p>
+                      <a:pPr lvl="0" indent="0" marL="0" algn="ctr">
+                        <a:buNone/>
+                      </a:pPr>
+                      <a:r>
+                        <a:rPr/>
+                        <a:t>R² &gt; 0.5</a:t>
+                      </a:r>
+                    </a:p>
+                  </a:txBody>
+                  <a:tcPr/>
+                </a:tc>
+                <a:tc>
+                  <a:txBody>
+                    <a:bodyPr/>
+                    <a:lstStyle/>
+                    <a:p>
+                      <a:pPr lvl="0" indent="0" marL="0" algn="ctr">
+                        <a:buNone/>
+                      </a:pPr>
+                      <a:r>
+                        <a:rPr/>
+                        <a:t>ANOVA sig.</a:t>
+                      </a:r>
+                    </a:p>
+                  </a:txBody>
+                  <a:tcPr/>
+                </a:tc>
+                <a:tc>
+                  <a:txBody>
+                    <a:bodyPr/>
+                    <a:lstStyle/>
+                    <a:p>
+                      <a:pPr lvl="0" indent="0" marL="0" algn="ctr">
+                        <a:buNone/>
+                      </a:pPr>
+                      <a:r>
+                        <a:rPr/>
+                        <a:t>Intercept sig.</a:t>
+                      </a:r>
+                    </a:p>
+                  </a:txBody>
+                  <a:tcPr/>
+                </a:tc>
+                <a:tc>
+                  <a:txBody>
+                    <a:bodyPr/>
+                    <a:lstStyle/>
+                    <a:p>
+                      <a:pPr lvl="0" indent="0" marL="0" algn="ctr">
+                        <a:buNone/>
+                      </a:pPr>
+                      <a:r>
+                        <a:rPr/>
+                        <a:t>Coef sig.</a:t>
+                      </a:r>
+                    </a:p>
+                  </a:txBody>
+                  <a:tcPr/>
+                </a:tc>
+                <a:tc>
+                  <a:txBody>
+                    <a:bodyPr/>
+                    <a:lstStyle/>
+                    <a:p>
+                      <a:pPr lvl="0" indent="0" marL="0" algn="ctr">
+                        <a:buNone/>
+                      </a:pPr>
+                      <a:r>
+                        <a:rPr/>
+                        <a:t>BLUE</a:t>
+                      </a:r>
+                    </a:p>
+                  </a:txBody>
+                  <a:tcPr/>
+                </a:tc>
+              </a:tr>
+              <a:tr h="0">
+                <a:tc>
+                  <a:txBody>
+                    <a:bodyPr/>
+                    <a:lstStyle/>
+                    <a:p>
+                      <a:pPr lvl="0" indent="0" marL="0" algn="l">
+                        <a:buNone/>
+                      </a:pPr>
+                      <a:r>
+                        <a:rPr/>
+                        <a:t>cyl</a:t>
+                      </a:r>
+                    </a:p>
+                  </a:txBody>
+                </a:tc>
+                <a:tc>
+                  <a:txBody>
+                    <a:bodyPr/>
+                    <a:lstStyle/>
+                    <a:p>
+                      <a:pPr lvl="0" indent="0" marL="0" algn="ctr">
+                        <a:buNone/>
+                      </a:pPr>
+                      <a:r>
+                        <a:rPr/>
+                        <a:t>Yes (0.73)</a:t>
+                      </a:r>
+                    </a:p>
+                  </a:txBody>
+                </a:tc>
+                <a:tc>
+                  <a:txBody>
+                    <a:bodyPr/>
+                    <a:lstStyle/>
+                    <a:p>
+                      <a:pPr lvl="0" indent="0" marL="0" algn="ctr">
+                        <a:buNone/>
+                      </a:pPr>
+                      <a:r>
+                        <a:rPr/>
+                        <a:t>Yes (&lt;0.001)</a:t>
+                      </a:r>
+                    </a:p>
+                  </a:txBody>
+                </a:tc>
+                <a:tc>
+                  <a:txBody>
+                    <a:bodyPr/>
+                    <a:lstStyle/>
+                    <a:p>
+                      <a:pPr lvl="0" indent="0" marL="0" algn="ctr">
+                        <a:buNone/>
+                      </a:pPr>
+                      <a:r>
+                        <a:rPr/>
+                        <a:t>Yes (&lt;0.001)</a:t>
+                      </a:r>
+                    </a:p>
+                  </a:txBody>
+                </a:tc>
+                <a:tc>
+                  <a:txBody>
+                    <a:bodyPr/>
+                    <a:lstStyle/>
+                    <a:p>
+                      <a:pPr lvl="0" indent="0" marL="0" algn="ctr">
+                        <a:buNone/>
+                      </a:pPr>
+                      <a:r>
+                        <a:rPr/>
+                        <a:t>Yes (&lt;0.001)</a:t>
+                      </a:r>
+                    </a:p>
+                  </a:txBody>
+                </a:tc>
+                <a:tc>
+                  <a:txBody>
+                    <a:bodyPr/>
+                    <a:lstStyle/>
+                    <a:p>
+                      <a:pPr lvl="0" indent="0" marL="0" algn="ctr">
+                        <a:buNone/>
+                      </a:pPr>
+                      <a:r>
+                        <a:rPr/>
+                        <a:t>Yes</a:t>
+                      </a:r>
+                    </a:p>
+                  </a:txBody>
+                </a:tc>
+              </a:tr>
+              <a:tr h="0">
+                <a:tc>
+                  <a:txBody>
+                    <a:bodyPr/>
+                    <a:lstStyle/>
+                    <a:p>
+                      <a:pPr lvl="0" indent="0" marL="0" algn="l">
+                        <a:buNone/>
+                      </a:pPr>
+                      <a:r>
+                        <a:rPr/>
+                        <a:t>wt</a:t>
+                      </a:r>
+                    </a:p>
+                  </a:txBody>
+                </a:tc>
+                <a:tc>
+                  <a:txBody>
+                    <a:bodyPr/>
+                    <a:lstStyle/>
+                    <a:p>
+                      <a:pPr lvl="0" indent="0" marL="0" algn="ctr">
+                        <a:buNone/>
+                      </a:pPr>
+                      <a:r>
+                        <a:rPr/>
+                        <a:t>Yes (0.73)</a:t>
+                      </a:r>
+                    </a:p>
+                  </a:txBody>
+                </a:tc>
+                <a:tc>
+                  <a:txBody>
+                    <a:bodyPr/>
+                    <a:lstStyle/>
+                    <a:p>
+                      <a:pPr lvl="0" indent="0" marL="0" algn="ctr">
+                        <a:buNone/>
+                      </a:pPr>
+                      <a:r>
+                        <a:rPr/>
+                        <a:t>Yes (&lt;0.001)</a:t>
+                      </a:r>
+                    </a:p>
+                  </a:txBody>
+                </a:tc>
+                <a:tc>
+                  <a:txBody>
+                    <a:bodyPr/>
+                    <a:lstStyle/>
+                    <a:p>
+                      <a:pPr lvl="0" indent="0" marL="0" algn="ctr">
+                        <a:buNone/>
+                      </a:pPr>
+                      <a:r>
+                        <a:rPr/>
+                        <a:t>Yes (&lt;0.001)</a:t>
+                      </a:r>
+                    </a:p>
+                  </a:txBody>
+                </a:tc>
+                <a:tc>
+                  <a:txBody>
+                    <a:bodyPr/>
+                    <a:lstStyle/>
+                    <a:p>
+                      <a:pPr lvl="0" indent="0" marL="0" algn="ctr">
+                        <a:buNone/>
+                      </a:pPr>
+                      <a:r>
+                        <a:rPr/>
+                        <a:t>Yes (&lt;0.001)</a:t>
+                      </a:r>
+                    </a:p>
+                  </a:txBody>
+                </a:tc>
+                <a:tc>
+                  <a:txBody>
+                    <a:bodyPr/>
+                    <a:lstStyle/>
+                    <a:p>
+                      <a:pPr lvl="0" indent="0" marL="0" algn="ctr">
+                        <a:buNone/>
+                      </a:pPr>
+                      <a:r>
+                        <a:rPr/>
+                        <a:t>Yes</a:t>
+                      </a:r>
+                    </a:p>
+                  </a:txBody>
+                </a:tc>
+              </a:tr>
+              <a:tr h="0">
+                <a:tc>
+                  <a:txBody>
+                    <a:bodyPr/>
+                    <a:lstStyle/>
+                    <a:p>
+                      <a:pPr lvl="0" indent="0" marL="0" algn="l">
+                        <a:buNone/>
+                      </a:pPr>
+                      <a:r>
+                        <a:rPr/>
+                        <a:t>disp</a:t>
+                      </a:r>
+                    </a:p>
+                  </a:txBody>
+                </a:tc>
+                <a:tc>
+                  <a:txBody>
+                    <a:bodyPr/>
+                    <a:lstStyle/>
+                    <a:p>
+                      <a:pPr lvl="0" indent="0" marL="0" algn="ctr">
+                        <a:buNone/>
+                      </a:pPr>
+                      <a:r>
+                        <a:rPr/>
+                        <a:t>Yes (0.68)</a:t>
+                      </a:r>
+                    </a:p>
+                  </a:txBody>
+                </a:tc>
+                <a:tc>
+                  <a:txBody>
+                    <a:bodyPr/>
+                    <a:lstStyle/>
+                    <a:p>
+                      <a:pPr lvl="0" indent="0" marL="0" algn="ctr">
+                        <a:buNone/>
+                      </a:pPr>
+                      <a:r>
+                        <a:rPr/>
+                        <a:t>Yes (&lt;0.001)</a:t>
+                      </a:r>
+                    </a:p>
+                  </a:txBody>
+                </a:tc>
+                <a:tc>
+                  <a:txBody>
+                    <a:bodyPr/>
+                    <a:lstStyle/>
+                    <a:p>
+                      <a:pPr lvl="0" indent="0" marL="0" algn="ctr">
+                        <a:buNone/>
+                      </a:pPr>
+                      <a:r>
+                        <a:rPr/>
+                        <a:t>Yes (&lt;0.001)</a:t>
+                      </a:r>
+                    </a:p>
+                  </a:txBody>
+                </a:tc>
+                <a:tc>
+                  <a:txBody>
+                    <a:bodyPr/>
+                    <a:lstStyle/>
+                    <a:p>
+                      <a:pPr lvl="0" indent="0" marL="0" algn="ctr">
+                        <a:buNone/>
+                      </a:pPr>
+                      <a:r>
+                        <a:rPr/>
+                        <a:t>Yes (&lt;0.001)</a:t>
+                      </a:r>
+                    </a:p>
+                  </a:txBody>
+                </a:tc>
+                <a:tc>
+                  <a:txBody>
+                    <a:bodyPr/>
+                    <a:lstStyle/>
+                    <a:p>
+                      <a:pPr lvl="0" indent="0" marL="0" algn="ctr">
+                        <a:buNone/>
+                      </a:pPr>
+                      <a:r>
+                        <a:rPr/>
+                        <a:t>Yes</a:t>
+                      </a:r>
+                    </a:p>
+                  </a:txBody>
+                </a:tc>
+              </a:tr>
+              <a:tr h="0">
+                <a:tc>
+                  <a:txBody>
+                    <a:bodyPr/>
+                    <a:lstStyle/>
+                    <a:p>
+                      <a:pPr lvl="0" indent="0" marL="0" algn="l">
+                        <a:buNone/>
+                      </a:pPr>
+                      <a:r>
+                        <a:rPr/>
+                        <a:t>hp</a:t>
+                      </a:r>
+                    </a:p>
+                  </a:txBody>
+                </a:tc>
+                <a:tc>
+                  <a:txBody>
+                    <a:bodyPr/>
+                    <a:lstStyle/>
+                    <a:p>
+                      <a:pPr lvl="0" indent="0" marL="0" algn="ctr">
+                        <a:buNone/>
+                      </a:pPr>
+                      <a:r>
+                        <a:rPr/>
+                        <a:t>Yes (0.57)</a:t>
+                      </a:r>
+                    </a:p>
+                  </a:txBody>
+                </a:tc>
+                <a:tc>
+                  <a:txBody>
+                    <a:bodyPr/>
+                    <a:lstStyle/>
+                    <a:p>
+                      <a:pPr lvl="0" indent="0" marL="0" algn="ctr">
+                        <a:buNone/>
+                      </a:pPr>
+                      <a:r>
+                        <a:rPr/>
+                        <a:t>Yes (&lt;0.001)</a:t>
+                      </a:r>
+                    </a:p>
+                  </a:txBody>
+                </a:tc>
+                <a:tc>
+                  <a:txBody>
+                    <a:bodyPr/>
+                    <a:lstStyle/>
+                    <a:p>
+                      <a:pPr lvl="0" indent="0" marL="0" algn="ctr">
+                        <a:buNone/>
+                      </a:pPr>
+                      <a:r>
+                        <a:rPr/>
+                        <a:t>Yes (&lt;0.001)</a:t>
+                      </a:r>
+                    </a:p>
+                  </a:txBody>
+                </a:tc>
+                <a:tc>
+                  <a:txBody>
+                    <a:bodyPr/>
+                    <a:lstStyle/>
+                    <a:p>
+                      <a:pPr lvl="0" indent="0" marL="0" algn="ctr">
+                        <a:buNone/>
+                      </a:pPr>
+                      <a:r>
+                        <a:rPr/>
+                        <a:t>Yes (&lt;0.001)</a:t>
+                      </a:r>
+                    </a:p>
+                  </a:txBody>
+                </a:tc>
+                <a:tc>
+                  <a:txBody>
+                    <a:bodyPr/>
+                    <a:lstStyle/>
+                    <a:p>
+                      <a:pPr lvl="0" indent="0" marL="0" algn="ctr">
+                        <a:buNone/>
+                      </a:pPr>
+                      <a:r>
+                        <a:rPr/>
+                        <a:t>Yes</a:t>
+                      </a:r>
+                    </a:p>
+                  </a:txBody>
+                </a:tc>
+              </a:tr>
+              <a:tr h="0">
+                <a:tc>
+                  <a:txBody>
+                    <a:bodyPr/>
+                    <a:lstStyle/>
+                    <a:p>
+                      <a:pPr lvl="0" indent="0" marL="0" algn="l">
+                        <a:buNone/>
+                      </a:pPr>
+                      <a:r>
+                        <a:rPr/>
+                        <a:t>drat</a:t>
+                      </a:r>
+                    </a:p>
+                  </a:txBody>
+                </a:tc>
+                <a:tc>
+                  <a:txBody>
+                    <a:bodyPr/>
+                    <a:lstStyle/>
+                    <a:p>
+                      <a:pPr lvl="0" indent="0" marL="0" algn="ctr">
+                        <a:buNone/>
+                      </a:pPr>
+                      <a:r>
+                        <a:rPr/>
+                        <a:t>Yes (0.53)</a:t>
+                      </a:r>
+                    </a:p>
+                  </a:txBody>
+                </a:tc>
+                <a:tc>
+                  <a:txBody>
+                    <a:bodyPr/>
+                    <a:lstStyle/>
+                    <a:p>
+                      <a:pPr lvl="0" indent="0" marL="0" algn="ctr">
+                        <a:buNone/>
+                      </a:pPr>
+                      <a:r>
+                        <a:rPr/>
+                        <a:t>Yes (&lt;0.001)</a:t>
+                      </a:r>
+                    </a:p>
+                  </a:txBody>
+                </a:tc>
+                <a:tc>
+                  <a:txBody>
+                    <a:bodyPr/>
+                    <a:lstStyle/>
+                    <a:p>
+                      <a:pPr lvl="0" indent="0" marL="0" algn="ctr">
+                        <a:buNone/>
+                      </a:pPr>
+                      <a:r>
+                        <a:rPr/>
+                        <a:t>No (0.249)</a:t>
+                      </a:r>
+                    </a:p>
+                  </a:txBody>
+                </a:tc>
+                <a:tc>
+                  <a:txBody>
+                    <a:bodyPr/>
+                    <a:lstStyle/>
+                    <a:p>
+                      <a:pPr lvl="0" indent="0" marL="0" algn="ctr">
+                        <a:buNone/>
+                      </a:pPr>
+                      <a:r>
+                        <a:rPr/>
+                        <a:t>Yes (&lt;0.001)</a:t>
+                      </a:r>
+                    </a:p>
+                  </a:txBody>
+                </a:tc>
+                <a:tc>
+                  <a:txBody>
+                    <a:bodyPr/>
+                    <a:lstStyle/>
+                    <a:p>
+                      <a:pPr lvl="0" indent="0" marL="0" algn="ctr">
+                        <a:buNone/>
+                      </a:pPr>
+                      <a:r>
+                        <a:rPr/>
+                        <a:t>No</a:t>
+                      </a:r>
+                    </a:p>
+                  </a:txBody>
+                </a:tc>
+              </a:tr>
+              <a:tr h="0">
+                <a:tc>
+                  <a:txBody>
+                    <a:bodyPr/>
+                    <a:lstStyle/>
+                    <a:p>
+                      <a:pPr lvl="0" indent="0" marL="0" algn="l">
+                        <a:buNone/>
+                      </a:pPr>
+                      <a:r>
+                        <a:rPr/>
+                        <a:t>qsec</a:t>
+                      </a:r>
+                    </a:p>
+                  </a:txBody>
+                </a:tc>
+                <a:tc>
+                  <a:txBody>
+                    <a:bodyPr/>
+                    <a:lstStyle/>
+                    <a:p>
+                      <a:pPr lvl="0" indent="0" marL="0" algn="ctr">
+                        <a:buNone/>
+                      </a:pPr>
+                      <a:r>
+                        <a:rPr/>
+                        <a:t>No (0.23)</a:t>
+                      </a:r>
+                    </a:p>
+                  </a:txBody>
+                </a:tc>
+                <a:tc>
+                  <a:txBody>
+                    <a:bodyPr/>
+                    <a:lstStyle/>
+                    <a:p>
+                      <a:pPr lvl="0" indent="0" marL="0" algn="ctr">
+                        <a:buNone/>
+                      </a:pPr>
+                      <a:r>
+                        <a:rPr/>
+                        <a:t>Yes (0.031)</a:t>
+                      </a:r>
+                    </a:p>
+                  </a:txBody>
+                </a:tc>
+                <a:tc>
+                  <a:txBody>
+                    <a:bodyPr/>
+                    <a:lstStyle/>
+                    <a:p>
+                      <a:pPr lvl="0" indent="0" marL="0" algn="ctr">
+                        <a:buNone/>
+                      </a:pPr>
+                      <a:r>
+                        <a:rPr/>
+                        <a:t>No (0.424)</a:t>
+                      </a:r>
+                    </a:p>
+                  </a:txBody>
+                </a:tc>
+                <a:tc>
+                  <a:txBody>
+                    <a:bodyPr/>
+                    <a:lstStyle/>
+                    <a:p>
+                      <a:pPr lvl="0" indent="0" marL="0" algn="ctr">
+                        <a:buNone/>
+                      </a:pPr>
+                      <a:r>
+                        <a:rPr/>
+                        <a:t>Yes (0.031)</a:t>
+                      </a:r>
+                    </a:p>
+                  </a:txBody>
+                </a:tc>
+                <a:tc>
+                  <a:txBody>
+                    <a:bodyPr/>
+                    <a:lstStyle/>
+                    <a:p>
+                      <a:pPr lvl="0" indent="0" marL="0" algn="ctr">
+                        <a:buNone/>
+                      </a:pPr>
+                      <a:r>
+                        <a:rPr/>
+                        <a:t>No</a:t>
+                      </a:r>
+                    </a:p>
+                  </a:txBody>
+                </a:tc>
+              </a:tr>
+              <a:tr h="0">
+                <a:tc>
+                  <a:txBody>
+                    <a:bodyPr/>
+                    <a:lstStyle/>
+                    <a:p>
+                      <a:pPr lvl="0" indent="0" marL="0" algn="l">
+                        <a:buNone/>
+                      </a:pPr>
+                      <a:r>
+                        <a:rPr/>
+                        <a:t>vs</a:t>
+                      </a:r>
+                    </a:p>
+                  </a:txBody>
+                </a:tc>
+                <a:tc>
+                  <a:txBody>
+                    <a:bodyPr/>
+                    <a:lstStyle/>
+                    <a:p>
+                      <a:pPr lvl="0" indent="0" marL="0" algn="ctr">
+                        <a:buNone/>
+                      </a:pPr>
+                      <a:r>
+                        <a:rPr/>
+                        <a:t>No (0.36)</a:t>
+                      </a:r>
+                    </a:p>
+                  </a:txBody>
+                </a:tc>
+                <a:tc>
+                  <a:txBody>
+                    <a:bodyPr/>
+                    <a:lstStyle/>
+                    <a:p>
+                      <a:pPr lvl="0" indent="0" marL="0" algn="ctr">
+                        <a:buNone/>
+                      </a:pPr>
+                      <a:r>
+                        <a:rPr/>
+                        <a:t>Yes (0.005)</a:t>
+                      </a:r>
+                    </a:p>
+                  </a:txBody>
+                </a:tc>
+                <a:tc>
+                  <a:txBody>
+                    <a:bodyPr/>
+                    <a:lstStyle/>
+                    <a:p>
+                      <a:pPr lvl="0" indent="0" marL="0" algn="ctr">
+                        <a:buNone/>
+                      </a:pPr>
+                      <a:r>
+                        <a:rPr/>
+                        <a:t>Yes (&lt;0.001)</a:t>
+                      </a:r>
+                    </a:p>
+                  </a:txBody>
+                </a:tc>
+                <a:tc>
+                  <a:txBody>
+                    <a:bodyPr/>
+                    <a:lstStyle/>
+                    <a:p>
+                      <a:pPr lvl="0" indent="0" marL="0" algn="ctr">
+                        <a:buNone/>
+                      </a:pPr>
+                      <a:r>
+                        <a:rPr/>
+                        <a:t>Yes (0.005)</a:t>
+                      </a:r>
+                    </a:p>
+                  </a:txBody>
+                </a:tc>
+                <a:tc>
+                  <a:txBody>
+                    <a:bodyPr/>
+                    <a:lstStyle/>
+                    <a:p>
+                      <a:pPr lvl="0" indent="0" marL="0" algn="ctr">
+                        <a:buNone/>
+                      </a:pPr>
+                      <a:r>
+                        <a:rPr/>
+                        <a:t>No</a:t>
+                      </a:r>
+                    </a:p>
+                  </a:txBody>
+                </a:tc>
+              </a:tr>
+              <a:tr h="0">
+                <a:tc>
+                  <a:txBody>
+                    <a:bodyPr/>
+                    <a:lstStyle/>
+                    <a:p>
+                      <a:pPr lvl="0" indent="0" marL="0" algn="l">
+                        <a:buNone/>
+                      </a:pPr>
+                      <a:r>
+                        <a:rPr/>
+                        <a:t>am</a:t>
+                      </a:r>
+                    </a:p>
+                  </a:txBody>
+                </a:tc>
+                <a:tc>
+                  <a:txBody>
+                    <a:bodyPr/>
+                    <a:lstStyle/>
+                    <a:p>
+                      <a:pPr lvl="0" indent="0" marL="0" algn="ctr">
+                        <a:buNone/>
+                      </a:pPr>
+                      <a:r>
+                        <a:rPr/>
+                        <a:t>No (0.41)</a:t>
+                      </a:r>
+                    </a:p>
+                  </a:txBody>
+                </a:tc>
+                <a:tc>
+                  <a:txBody>
+                    <a:bodyPr/>
+                    <a:lstStyle/>
+                    <a:p>
+                      <a:pPr lvl="0" indent="0" marL="0" algn="ctr">
+                        <a:buNone/>
+                      </a:pPr>
+                      <a:r>
+                        <a:rPr/>
+                        <a:t>Yes (0.002)</a:t>
+                      </a:r>
+                    </a:p>
+                  </a:txBody>
+                </a:tc>
+                <a:tc>
+                  <a:txBody>
+                    <a:bodyPr/>
+                    <a:lstStyle/>
+                    <a:p>
+                      <a:pPr lvl="0" indent="0" marL="0" algn="ctr">
+                        <a:buNone/>
+                      </a:pPr>
+                      <a:r>
+                        <a:rPr/>
+                        <a:t>Yes (&lt;0.001)</a:t>
+                      </a:r>
+                    </a:p>
+                  </a:txBody>
+                </a:tc>
+                <a:tc>
+                  <a:txBody>
+                    <a:bodyPr/>
+                    <a:lstStyle/>
+                    <a:p>
+                      <a:pPr lvl="0" indent="0" marL="0" algn="ctr">
+                        <a:buNone/>
+                      </a:pPr>
+                      <a:r>
+                        <a:rPr/>
+                        <a:t>Yes (0.002)</a:t>
+                      </a:r>
+                    </a:p>
+                  </a:txBody>
+                </a:tc>
+                <a:tc>
+                  <a:txBody>
+                    <a:bodyPr/>
+                    <a:lstStyle/>
+                    <a:p>
+                      <a:pPr lvl="0" indent="0" marL="0" algn="ctr">
+                        <a:buNone/>
+                      </a:pPr>
+                      <a:r>
+                        <a:rPr/>
+                        <a:t>No</a:t>
+                      </a:r>
+                    </a:p>
+                  </a:txBody>
+                </a:tc>
+              </a:tr>
+              <a:tr h="0">
+                <a:tc>
+                  <a:txBody>
+                    <a:bodyPr/>
+                    <a:lstStyle/>
+                    <a:p>
+                      <a:pPr lvl="0" indent="0" marL="0" algn="l">
+                        <a:buNone/>
+                      </a:pPr>
+                      <a:r>
+                        <a:rPr/>
+                        <a:t>gear</a:t>
+                      </a:r>
+                    </a:p>
+                  </a:txBody>
+                </a:tc>
+                <a:tc>
+                  <a:txBody>
+                    <a:bodyPr/>
+                    <a:lstStyle/>
+                    <a:p>
+                      <a:pPr lvl="0" indent="0" marL="0" algn="ctr">
+                        <a:buNone/>
+                      </a:pPr>
+                      <a:r>
+                        <a:rPr/>
+                        <a:t>No (0.19)</a:t>
+                      </a:r>
+                    </a:p>
+                  </a:txBody>
+                </a:tc>
+                <a:tc>
+                  <a:txBody>
+                    <a:bodyPr/>
+                    <a:lstStyle/>
+                    <a:p>
+                      <a:pPr lvl="0" indent="0" marL="0" algn="ctr">
+                        <a:buNone/>
+                      </a:pPr>
+                      <a:r>
+                        <a:rPr/>
+                        <a:t>No (0.052)</a:t>
+                      </a:r>
+                    </a:p>
+                  </a:txBody>
+                </a:tc>
+                <a:tc>
+                  <a:txBody>
+                    <a:bodyPr/>
+                    <a:lstStyle/>
+                    <a:p>
+                      <a:pPr lvl="0" indent="0" marL="0" algn="ctr">
+                        <a:buNone/>
+                      </a:pPr>
+                      <a:r>
+                        <a:rPr/>
+                        <a:t>No (0.341)</a:t>
+                      </a:r>
+                    </a:p>
+                  </a:txBody>
+                </a:tc>
+                <a:tc>
+                  <a:txBody>
+                    <a:bodyPr/>
+                    <a:lstStyle/>
+                    <a:p>
+                      <a:pPr lvl="0" indent="0" marL="0" algn="ctr">
+                        <a:buNone/>
+                      </a:pPr>
+                      <a:r>
+                        <a:rPr/>
+                        <a:t>No (0.052)</a:t>
+                      </a:r>
+                    </a:p>
+                  </a:txBody>
+                </a:tc>
+                <a:tc>
+                  <a:txBody>
+                    <a:bodyPr/>
+                    <a:lstStyle/>
+                    <a:p>
+                      <a:pPr lvl="0" indent="0" marL="0" algn="ctr">
+                        <a:buNone/>
+                      </a:pPr>
+                      <a:r>
+                        <a:rPr/>
+                        <a:t>No</a:t>
+                      </a:r>
+                    </a:p>
+                  </a:txBody>
+                </a:tc>
+              </a:tr>
+              <a:tr h="0">
+                <a:tc>
+                  <a:txBody>
+                    <a:bodyPr/>
+                    <a:lstStyle/>
+                    <a:p>
+                      <a:pPr lvl="0" indent="0" marL="0" algn="l">
+                        <a:buNone/>
+                      </a:pPr>
+                      <a:r>
+                        <a:rPr/>
+                        <a:t>carb</a:t>
+                      </a:r>
+                    </a:p>
+                  </a:txBody>
+                </a:tc>
+                <a:tc>
+                  <a:txBody>
+                    <a:bodyPr/>
+                    <a:lstStyle/>
+                    <a:p>
+                      <a:pPr lvl="0" indent="0" marL="0" algn="ctr">
+                        <a:buNone/>
+                      </a:pPr>
+                      <a:r>
+                        <a:rPr/>
+                        <a:t>No (0.34)</a:t>
+                      </a:r>
+                    </a:p>
+                  </a:txBody>
+                </a:tc>
+                <a:tc>
+                  <a:txBody>
+                    <a:bodyPr/>
+                    <a:lstStyle/>
+                    <a:p>
+                      <a:pPr lvl="0" indent="0" marL="0" algn="ctr">
+                        <a:buNone/>
+                      </a:pPr>
+                      <a:r>
+                        <a:rPr/>
+                        <a:t>Yes (0.007)</a:t>
+                      </a:r>
+                    </a:p>
+                  </a:txBody>
+                </a:tc>
+                <a:tc>
+                  <a:txBody>
+                    <a:bodyPr/>
+                    <a:lstStyle/>
+                    <a:p>
+                      <a:pPr lvl="0" indent="0" marL="0" algn="ctr">
+                        <a:buNone/>
+                      </a:pPr>
+                      <a:r>
+                        <a:rPr/>
+                        <a:t>Yes (&lt;0.001)</a:t>
+                      </a:r>
+                    </a:p>
+                  </a:txBody>
+                </a:tc>
+                <a:tc>
+                  <a:txBody>
+                    <a:bodyPr/>
+                    <a:lstStyle/>
+                    <a:p>
+                      <a:pPr lvl="0" indent="0" marL="0" algn="ctr">
+                        <a:buNone/>
+                      </a:pPr>
+                      <a:r>
+                        <a:rPr/>
+                        <a:t>Yes (0.007)</a:t>
+                      </a:r>
+                    </a:p>
+                  </a:txBody>
+                </a:tc>
+                <a:tc>
+                  <a:txBody>
+                    <a:bodyPr/>
+                    <a:lstStyle/>
+                    <a:p>
+                      <a:pPr lvl="0" indent="0" marL="0" algn="ctr">
+                        <a:buNone/>
+                      </a:pPr>
+                      <a:r>
+                        <a:rPr/>
+                        <a:t>No</a:t>
+                      </a:r>
+                    </a:p>
+                  </a:txBody>
+                </a:tc>
+              </a:tr>
+            </a:tbl>
+          </a:graphicData>
+        </a:graphic>
+      </p:graphicFrame>
+    </p:spTree>
+  </p:cSld>
+</p:sld>
+</file>
+
+<file path=ppt/slides/slide6.xml><?xml version="1.0" encoding="utf-8"?>
+<p:sld xmlns:a="http://schemas.openxmlformats.org/drawingml/2006/main" xmlns:r="http://schemas.openxmlformats.org/officeDocument/2006/relationships" xmlns:p="http://schemas.openxmlformats.org/presentationml/2006/main">
+  <p:cSld>
+    <p:spTree>
+      <p:nvGrpSpPr>
+        <p:cNvPr id="1" name=""/>
+        <p:cNvGrpSpPr/>
+        <p:nvPr/>
+      </p:nvGrpSpPr>
+      <p:grpSpPr>
+        <a:xfrm>
+          <a:off x="0" y="0"/>
+          <a:ext cx="0" cy="0"/>
+          <a:chOff x="0" y="0"/>
+          <a:chExt cx="0" cy="0"/>
+        </a:xfrm>
+      </p:grpSpPr>
+      <p:sp>
+        <p:nvSpPr>
+          <p:cNvPr id="4" name="Text Placeholder 3"/>
+          <p:cNvSpPr>
+            <a:spLocks noGrp="1"/>
+          </p:cNvSpPr>
+          <p:nvPr>
+            <p:ph idx="2" sz="half" type="body"/>
+          </p:nvPr>
+        </p:nvSpPr>
+        <p:spPr/>
+        <p:txBody>
+          <a:bodyPr/>
+          <a:lstStyle/>
           <a:p>
             <a:pPr lvl="0" indent="0" marL="0">
               <a:buNone/>
             </a:pPr>
             <a:r>
               <a:rPr b="1"/>
-              <a:t>Top Performing Variables (R² values):</a:t>
-            </a:r>
-          </a:p>
-          <a:p>
-            <a:pPr lvl="0" indent="0">
-              <a:buNone/>
-            </a:pPr>
-            <a:r>
-              <a:rPr>
-                <a:latin typeface="Courier"/>
-              </a:rPr>
-              <a:t>cyl: 73.2% (p = 0.0000014968)
-wt: 73.2% (p = 0.0000015375)
-disp: 67.9% (p = 0.0000080226)
-hp: 56.8% (p = 0.0001238260)</a:t>
+              <a:t>BLUE Requirements:</a:t>
+            </a:r>
+            <a:r>
+              <a:rPr/>
+              <a:t> - R² &gt; 0.5 indicates good model fit - All significance tests must have p &lt; 0.05 - Model must pass all criteria to be BLUE</a:t>
             </a:r>
           </a:p>
           <a:p>
@@ -4458,7 +5825,7 @@
       </p:sp>
       <p:pic>
         <p:nvPicPr>
-          <p:cNvPr descr="supervised_learning_files/figure-pptx/unnamed-chunk-6-1.png" id="0" name="Picture 1"/>
+          <p:cNvPr descr="supervised_learning_files/figure-pptx/unnamed-chunk-7-1.png" id="0" name="Picture 1"/>
           <p:cNvPicPr>
             <a:picLocks noGrp="1" noChangeAspect="1"/>
           </p:cNvPicPr>
@@ -4491,325 +5858,6 @@
 </p:sld>
 </file>
 
-<file path=ppt/slides/slide5.xml><?xml version="1.0" encoding="utf-8"?>
-<p:sld xmlns:a="http://schemas.openxmlformats.org/drawingml/2006/main" xmlns:r="http://schemas.openxmlformats.org/officeDocument/2006/relationships" xmlns:p="http://schemas.openxmlformats.org/presentationml/2006/main">
-  <p:cSld>
-    <p:spTree>
-      <p:nvGrpSpPr>
-        <p:cNvPr id="1" name=""/>
-        <p:cNvGrpSpPr/>
-        <p:nvPr/>
-      </p:nvGrpSpPr>
-      <p:grpSpPr>
-        <a:xfrm>
-          <a:off x="0" y="0"/>
-          <a:ext cx="0" cy="0"/>
-          <a:chOff x="0" y="0"/>
-          <a:chExt cx="0" cy="0"/>
-        </a:xfrm>
-      </p:grpSpPr>
-      <p:sp>
-        <p:nvSpPr>
-          <p:cNvPr id="2" name="Title 1"/>
-          <p:cNvSpPr>
-            <a:spLocks noGrp="1"/>
-          </p:cNvSpPr>
-          <p:nvPr>
-            <p:ph type="title"/>
-          </p:nvPr>
-        </p:nvSpPr>
-        <p:spPr/>
-        <p:txBody>
-          <a:bodyPr/>
-          <a:lstStyle/>
-          <a:p>
-            <a:pPr lvl="0" indent="0" marL="0">
-              <a:buNone/>
-            </a:pPr>
-            <a:r>
-              <a:rPr/>
-              <a:t>Most Important Car Features</a:t>
-            </a:r>
-          </a:p>
-        </p:txBody>
-      </p:sp>
-      <p:sp>
-        <p:nvSpPr>
-          <p:cNvPr id="3" name="Content Placeholder 2"/>
-          <p:cNvSpPr>
-            <a:spLocks noGrp="1"/>
-          </p:cNvSpPr>
-          <p:nvPr>
-            <p:ph idx="1"/>
-          </p:nvPr>
-        </p:nvSpPr>
-        <p:spPr/>
-        <p:txBody>
-          <a:bodyPr/>
-          <a:lstStyle/>
-          <a:p>
-            <a:pPr lvl="0" indent="0" marL="0">
-              <a:spcBef>
-                <a:spcPts val="3000"/>
-              </a:spcBef>
-              <a:buNone/>
-            </a:pPr>
-            <a:r>
-              <a:rPr b="1"/>
-              <a:t>Key Findings from Analysis</a:t>
-            </a:r>
-          </a:p>
-          <a:p>
-            <a:pPr lvl="0" indent="0" marL="0">
-              <a:buNone/>
-            </a:pPr>
-            <a:r>
-              <a:rPr b="1"/>
-              <a:t>Top 4 Most Influential Features:</a:t>
-            </a:r>
-          </a:p>
-          <a:p>
-            <a:pPr lvl="0" indent="-342900" marL="342900">
-              <a:buAutoNum type="arabicPeriod"/>
-            </a:pPr>
-            <a:r>
-              <a:rPr b="1"/>
-              <a:t>Number of Cylinders (cyl)</a:t>
-            </a:r>
-            <a:r>
-              <a:rPr/>
-              <a:t> (R² = 73.24%)</a:t>
-            </a:r>
-          </a:p>
-          <a:p>
-            <a:pPr lvl="1"/>
-            <a:r>
-              <a:rPr/>
-              <a:t>Explains 73% of MPG variation.</a:t>
-            </a:r>
-          </a:p>
-          <a:p>
-            <a:pPr lvl="1"/>
-            <a:r>
-              <a:rPr/>
-              <a:t>Very strong relationship with fuel efficiency.</a:t>
-            </a:r>
-          </a:p>
-          <a:p>
-            <a:pPr lvl="0" indent="-342900" marL="342900">
-              <a:buAutoNum type="arabicPeriod"/>
-            </a:pPr>
-            <a:r>
-              <a:rPr b="1"/>
-              <a:t>Car Weight (wt)</a:t>
-            </a:r>
-            <a:r>
-              <a:rPr/>
-              <a:t> (R² = 73.16%)</a:t>
-            </a:r>
-          </a:p>
-          <a:p>
-            <a:pPr lvl="1"/>
-            <a:r>
-              <a:rPr/>
-              <a:t>Almost equally important as cylinders.</a:t>
-            </a:r>
-          </a:p>
-          <a:p>
-            <a:pPr lvl="1"/>
-            <a:r>
-              <a:rPr/>
-              <a:t>Heavier cars use more fuel.</a:t>
-            </a:r>
-          </a:p>
-          <a:p>
-            <a:pPr lvl="0" indent="-342900" marL="342900">
-              <a:buAutoNum type="arabicPeriod"/>
-            </a:pPr>
-            <a:r>
-              <a:rPr b="1"/>
-              <a:t>Engine Size (disp)</a:t>
-            </a:r>
-            <a:r>
-              <a:rPr/>
-              <a:t> (R² = 67.87%)</a:t>
-            </a:r>
-          </a:p>
-          <a:p>
-            <a:pPr lvl="1"/>
-            <a:r>
-              <a:rPr/>
-              <a:t>Larger engines typically use more fuel.</a:t>
-            </a:r>
-          </a:p>
-          <a:p>
-            <a:pPr lvl="1"/>
-            <a:r>
-              <a:rPr/>
-              <a:t>Strong predictor of MPG.</a:t>
-            </a:r>
-          </a:p>
-          <a:p>
-            <a:pPr lvl="0" indent="-342900" marL="342900">
-              <a:buAutoNum type="arabicPeriod"/>
-            </a:pPr>
-            <a:r>
-              <a:rPr b="1"/>
-              <a:t>Horsepower (hp)</a:t>
-            </a:r>
-            <a:r>
-              <a:rPr/>
-              <a:t> (R² = 56.83%)</a:t>
-            </a:r>
-          </a:p>
-          <a:p>
-            <a:pPr lvl="1"/>
-            <a:r>
-              <a:rPr/>
-              <a:t>More power means more fuel consumption.</a:t>
-            </a:r>
-          </a:p>
-          <a:p>
-            <a:pPr lvl="1"/>
-            <a:r>
-              <a:rPr/>
-              <a:t>Moderate to strong relationship.</a:t>
-            </a:r>
-          </a:p>
-          <a:p>
-            <a:pPr lvl="0" indent="0" marL="0">
-              <a:buNone/>
-            </a:pPr>
-            <a:r>
-              <a:rPr b="1"/>
-              <a:t>Why These Matter:</a:t>
-            </a:r>
-            <a:r>
-              <a:rPr/>
-              <a:t> - All have strong statistical evidence (p &lt; 0.05). - Each explains more than 50% of MPG variation. - Show clear relationships with fuel efficiency.</a:t>
-            </a:r>
-          </a:p>
-        </p:txBody>
-      </p:sp>
-    </p:spTree>
-  </p:cSld>
-</p:sld>
-</file>
-
-<file path=ppt/slides/slide6.xml><?xml version="1.0" encoding="utf-8"?>
-<p:sld xmlns:a="http://schemas.openxmlformats.org/drawingml/2006/main" xmlns:r="http://schemas.openxmlformats.org/officeDocument/2006/relationships" xmlns:p="http://schemas.openxmlformats.org/presentationml/2006/main">
-  <p:cSld>
-    <p:spTree>
-      <p:nvGrpSpPr>
-        <p:cNvPr id="1" name=""/>
-        <p:cNvGrpSpPr/>
-        <p:nvPr/>
-      </p:nvGrpSpPr>
-      <p:grpSpPr>
-        <a:xfrm>
-          <a:off x="0" y="0"/>
-          <a:ext cx="0" cy="0"/>
-          <a:chOff x="0" y="0"/>
-          <a:chExt cx="0" cy="0"/>
-        </a:xfrm>
-      </p:grpSpPr>
-      <p:sp>
-        <p:nvSpPr>
-          <p:cNvPr id="2" name="Title 1"/>
-          <p:cNvSpPr>
-            <a:spLocks noGrp="1"/>
-          </p:cNvSpPr>
-          <p:nvPr>
-            <p:ph type="title"/>
-          </p:nvPr>
-        </p:nvSpPr>
-        <p:spPr/>
-        <p:txBody>
-          <a:bodyPr/>
-          <a:lstStyle/>
-          <a:p>
-            <a:pPr lvl="0" indent="0" marL="0">
-              <a:buNone/>
-            </a:pPr>
-            <a:r>
-              <a:rPr/>
-              <a:t>Combining Car Features</a:t>
-            </a:r>
-          </a:p>
-        </p:txBody>
-      </p:sp>
-      <p:sp>
-        <p:nvSpPr>
-          <p:cNvPr id="3" name="Content Placeholder 2"/>
-          <p:cNvSpPr>
-            <a:spLocks noGrp="1"/>
-          </p:cNvSpPr>
-          <p:nvPr>
-            <p:ph idx="1"/>
-          </p:nvPr>
-        </p:nvSpPr>
-        <p:spPr/>
-        <p:txBody>
-          <a:bodyPr/>
-          <a:lstStyle/>
-          <a:p>
-            <a:pPr lvl="0" indent="0" marL="0">
-              <a:spcBef>
-                <a:spcPts val="3000"/>
-              </a:spcBef>
-              <a:buNone/>
-            </a:pPr>
-            <a:r>
-              <a:rPr b="1"/>
-              <a:t>Building a Better Model</a:t>
-            </a:r>
-          </a:p>
-          <a:p>
-            <a:pPr lvl="0" indent="0" marL="0">
-              <a:buNone/>
-            </a:pPr>
-            <a:r>
-              <a:rPr b="1"/>
-              <a:t>Initial Approach:</a:t>
-            </a:r>
-            <a:r>
-              <a:rPr/>
-              <a:t> - Combined all important features together - Found some features were too closely related - Needed to simplify the model</a:t>
-            </a:r>
-          </a:p>
-          <a:p>
-            <a:pPr lvl="0" indent="0" marL="0">
-              <a:buNone/>
-            </a:pPr>
-            <a:r>
-              <a:rPr b="1"/>
-              <a:t>Problem Found:</a:t>
-            </a:r>
-            <a:r>
-              <a:rPr/>
-              <a:t> - Engine size (disp) overlapped with other features - VIF Analysis showed redundant information: * Engine size VIF &gt; 10 (too high) * Other features had acceptable VIF values</a:t>
-            </a:r>
-          </a:p>
-          <a:p>
-            <a:pPr lvl="0" indent="0" marL="0">
-              <a:buNone/>
-            </a:pPr>
-            <a:r>
-              <a:rPr b="1"/>
-              <a:t>Final Model:</a:t>
-            </a:r>
-            <a:r>
-              <a:rPr/>
-              <a:t> - Kept three key features: 1. Car Weight (wt) 2. Horsepower (hp) 3. Transmission Type (am) - Removed redundant engine size measure. - Maintained prediction accuracy.</a:t>
-            </a:r>
-          </a:p>
-        </p:txBody>
-      </p:sp>
-    </p:spTree>
-  </p:cSld>
-</p:sld>
-</file>
-
 <file path=ppt/slides/slide7.xml><?xml version="1.0" encoding="utf-8"?>
 <p:sld xmlns:a="http://schemas.openxmlformats.org/drawingml/2006/main" xmlns:r="http://schemas.openxmlformats.org/officeDocument/2006/relationships" xmlns:p="http://schemas.openxmlformats.org/presentationml/2006/main">
   <p:cSld>
@@ -4837,6 +5885,325 @@
             <p:ph type="title"/>
           </p:nvPr>
         </p:nvSpPr>
+        <p:spPr/>
+        <p:txBody>
+          <a:bodyPr/>
+          <a:lstStyle/>
+          <a:p>
+            <a:pPr lvl="0" indent="0" marL="0">
+              <a:buNone/>
+            </a:pPr>
+            <a:r>
+              <a:rPr/>
+              <a:t>Most Important Car Features</a:t>
+            </a:r>
+          </a:p>
+        </p:txBody>
+      </p:sp>
+      <p:sp>
+        <p:nvSpPr>
+          <p:cNvPr id="3" name="Content Placeholder 2"/>
+          <p:cNvSpPr>
+            <a:spLocks noGrp="1"/>
+          </p:cNvSpPr>
+          <p:nvPr>
+            <p:ph idx="1"/>
+          </p:nvPr>
+        </p:nvSpPr>
+        <p:spPr/>
+        <p:txBody>
+          <a:bodyPr/>
+          <a:lstStyle/>
+          <a:p>
+            <a:pPr lvl="0" indent="0" marL="0">
+              <a:spcBef>
+                <a:spcPts val="3000"/>
+              </a:spcBef>
+              <a:buNone/>
+            </a:pPr>
+            <a:r>
+              <a:rPr b="1"/>
+              <a:t>Key Findings from Analysis</a:t>
+            </a:r>
+          </a:p>
+          <a:p>
+            <a:pPr lvl="0" indent="0" marL="0">
+              <a:buNone/>
+            </a:pPr>
+            <a:r>
+              <a:rPr b="1"/>
+              <a:t>Top 4 Most Influential Features:</a:t>
+            </a:r>
+          </a:p>
+          <a:p>
+            <a:pPr lvl="0" indent="-342900" marL="342900">
+              <a:buAutoNum type="arabicPeriod"/>
+            </a:pPr>
+            <a:r>
+              <a:rPr b="1"/>
+              <a:t>Number of Cylinders (cyl)</a:t>
+            </a:r>
+            <a:r>
+              <a:rPr/>
+              <a:t> (R² = 73.24%)</a:t>
+            </a:r>
+          </a:p>
+          <a:p>
+            <a:pPr lvl="1"/>
+            <a:r>
+              <a:rPr/>
+              <a:t>Explains 73% of MPG variation.</a:t>
+            </a:r>
+          </a:p>
+          <a:p>
+            <a:pPr lvl="1"/>
+            <a:r>
+              <a:rPr/>
+              <a:t>Very strong relationship with fuel efficiency.</a:t>
+            </a:r>
+          </a:p>
+          <a:p>
+            <a:pPr lvl="0" indent="-342900" marL="342900">
+              <a:buAutoNum type="arabicPeriod"/>
+            </a:pPr>
+            <a:r>
+              <a:rPr b="1"/>
+              <a:t>Car Weight (wt)</a:t>
+            </a:r>
+            <a:r>
+              <a:rPr/>
+              <a:t> (R² = 73.16%)</a:t>
+            </a:r>
+          </a:p>
+          <a:p>
+            <a:pPr lvl="1"/>
+            <a:r>
+              <a:rPr/>
+              <a:t>Almost equally important as cylinders.</a:t>
+            </a:r>
+          </a:p>
+          <a:p>
+            <a:pPr lvl="1"/>
+            <a:r>
+              <a:rPr/>
+              <a:t>Heavier cars use more fuel.</a:t>
+            </a:r>
+          </a:p>
+          <a:p>
+            <a:pPr lvl="0" indent="-342900" marL="342900">
+              <a:buAutoNum type="arabicPeriod"/>
+            </a:pPr>
+            <a:r>
+              <a:rPr b="1"/>
+              <a:t>Engine Size (disp)</a:t>
+            </a:r>
+            <a:r>
+              <a:rPr/>
+              <a:t> (R² = 67.87%)</a:t>
+            </a:r>
+          </a:p>
+          <a:p>
+            <a:pPr lvl="1"/>
+            <a:r>
+              <a:rPr/>
+              <a:t>Larger engines typically use more fuel.</a:t>
+            </a:r>
+          </a:p>
+          <a:p>
+            <a:pPr lvl="1"/>
+            <a:r>
+              <a:rPr/>
+              <a:t>Strong predictor of MPG.</a:t>
+            </a:r>
+          </a:p>
+          <a:p>
+            <a:pPr lvl="0" indent="-342900" marL="342900">
+              <a:buAutoNum type="arabicPeriod"/>
+            </a:pPr>
+            <a:r>
+              <a:rPr b="1"/>
+              <a:t>Horsepower (hp)</a:t>
+            </a:r>
+            <a:r>
+              <a:rPr/>
+              <a:t> (R² = 56.83%)</a:t>
+            </a:r>
+          </a:p>
+          <a:p>
+            <a:pPr lvl="1"/>
+            <a:r>
+              <a:rPr/>
+              <a:t>More power means more fuel consumption.</a:t>
+            </a:r>
+          </a:p>
+          <a:p>
+            <a:pPr lvl="1"/>
+            <a:r>
+              <a:rPr/>
+              <a:t>Moderate to strong relationship.</a:t>
+            </a:r>
+          </a:p>
+          <a:p>
+            <a:pPr lvl="0" indent="0" marL="0">
+              <a:buNone/>
+            </a:pPr>
+            <a:r>
+              <a:rPr b="1"/>
+              <a:t>Why These Matter:</a:t>
+            </a:r>
+            <a:r>
+              <a:rPr/>
+              <a:t> - All have strong statistical evidence (p &lt; 0.05). - Each explains more than 50% of MPG variation. - Show clear relationships with fuel efficiency.</a:t>
+            </a:r>
+          </a:p>
+        </p:txBody>
+      </p:sp>
+    </p:spTree>
+  </p:cSld>
+</p:sld>
+</file>
+
+<file path=ppt/slides/slide8.xml><?xml version="1.0" encoding="utf-8"?>
+<p:sld xmlns:a="http://schemas.openxmlformats.org/drawingml/2006/main" xmlns:r="http://schemas.openxmlformats.org/officeDocument/2006/relationships" xmlns:p="http://schemas.openxmlformats.org/presentationml/2006/main">
+  <p:cSld>
+    <p:spTree>
+      <p:nvGrpSpPr>
+        <p:cNvPr id="1" name=""/>
+        <p:cNvGrpSpPr/>
+        <p:nvPr/>
+      </p:nvGrpSpPr>
+      <p:grpSpPr>
+        <a:xfrm>
+          <a:off x="0" y="0"/>
+          <a:ext cx="0" cy="0"/>
+          <a:chOff x="0" y="0"/>
+          <a:chExt cx="0" cy="0"/>
+        </a:xfrm>
+      </p:grpSpPr>
+      <p:sp>
+        <p:nvSpPr>
+          <p:cNvPr id="2" name="Title 1"/>
+          <p:cNvSpPr>
+            <a:spLocks noGrp="1"/>
+          </p:cNvSpPr>
+          <p:nvPr>
+            <p:ph type="title"/>
+          </p:nvPr>
+        </p:nvSpPr>
+        <p:spPr/>
+        <p:txBody>
+          <a:bodyPr/>
+          <a:lstStyle/>
+          <a:p>
+            <a:pPr lvl="0" indent="0" marL="0">
+              <a:buNone/>
+            </a:pPr>
+            <a:r>
+              <a:rPr/>
+              <a:t>Combining Car Features</a:t>
+            </a:r>
+          </a:p>
+        </p:txBody>
+      </p:sp>
+      <p:sp>
+        <p:nvSpPr>
+          <p:cNvPr id="3" name="Content Placeholder 2"/>
+          <p:cNvSpPr>
+            <a:spLocks noGrp="1"/>
+          </p:cNvSpPr>
+          <p:nvPr>
+            <p:ph idx="1"/>
+          </p:nvPr>
+        </p:nvSpPr>
+        <p:spPr/>
+        <p:txBody>
+          <a:bodyPr/>
+          <a:lstStyle/>
+          <a:p>
+            <a:pPr lvl="0" indent="0" marL="0">
+              <a:spcBef>
+                <a:spcPts val="3000"/>
+              </a:spcBef>
+              <a:buNone/>
+            </a:pPr>
+            <a:r>
+              <a:rPr b="1"/>
+              <a:t>Building a Better Model</a:t>
+            </a:r>
+          </a:p>
+          <a:p>
+            <a:pPr lvl="0" indent="0" marL="0">
+              <a:buNone/>
+            </a:pPr>
+            <a:r>
+              <a:rPr b="1"/>
+              <a:t>Initial Approach:</a:t>
+            </a:r>
+            <a:r>
+              <a:rPr/>
+              <a:t> - Combined all important features together - Found some features were too closely related - Needed to simplify the model</a:t>
+            </a:r>
+          </a:p>
+          <a:p>
+            <a:pPr lvl="0" indent="0" marL="0">
+              <a:buNone/>
+            </a:pPr>
+            <a:r>
+              <a:rPr b="1"/>
+              <a:t>Problem Found:</a:t>
+            </a:r>
+            <a:r>
+              <a:rPr/>
+              <a:t> - Engine size (disp) overlapped with other features - VIF Analysis showed redundant information: * Engine size VIF &gt; 10 (too high) * Other features had acceptable VIF values</a:t>
+            </a:r>
+          </a:p>
+          <a:p>
+            <a:pPr lvl="0" indent="0" marL="0">
+              <a:buNone/>
+            </a:pPr>
+            <a:r>
+              <a:rPr b="1"/>
+              <a:t>Final Model:</a:t>
+            </a:r>
+            <a:r>
+              <a:rPr/>
+              <a:t> - Kept three key features: 1. Car Weight (wt) 2. Horsepower (hp) 3. Transmission Type (am) - Removed redundant engine size measure. - Maintained prediction accuracy.</a:t>
+            </a:r>
+          </a:p>
+        </p:txBody>
+      </p:sp>
+    </p:spTree>
+  </p:cSld>
+</p:sld>
+</file>
+
+<file path=ppt/slides/slide9.xml><?xml version="1.0" encoding="utf-8"?>
+<p:sld xmlns:a="http://schemas.openxmlformats.org/drawingml/2006/main" xmlns:r="http://schemas.openxmlformats.org/officeDocument/2006/relationships" xmlns:p="http://schemas.openxmlformats.org/presentationml/2006/main">
+  <p:cSld>
+    <p:spTree>
+      <p:nvGrpSpPr>
+        <p:cNvPr id="1" name=""/>
+        <p:cNvGrpSpPr/>
+        <p:nvPr/>
+      </p:nvGrpSpPr>
+      <p:grpSpPr>
+        <a:xfrm>
+          <a:off x="0" y="0"/>
+          <a:ext cx="0" cy="0"/>
+          <a:chOff x="0" y="0"/>
+          <a:chExt cx="0" cy="0"/>
+        </a:xfrm>
+      </p:grpSpPr>
+      <p:sp>
+        <p:nvSpPr>
+          <p:cNvPr id="2" name="Title 1"/>
+          <p:cNvSpPr>
+            <a:spLocks noGrp="1"/>
+          </p:cNvSpPr>
+          <p:nvPr>
+            <p:ph type="title"/>
+          </p:nvPr>
+        </p:nvSpPr>
         <p:spPr>
           <a:xfrm>
             <a:off x="457201" y="204787"/>
@@ -4994,7 +6361,7 @@
       </p:sp>
       <p:pic>
         <p:nvPicPr>
-          <p:cNvPr descr="supervised_learning_files/figure-pptx/unnamed-chunk-7-1.png" id="0" name="Picture 1"/>
+          <p:cNvPr descr="supervised_learning_files/figure-pptx/unnamed-chunk-8-1.png" id="0" name="Picture 1"/>
           <p:cNvPicPr>
             <a:picLocks noGrp="1" noChangeAspect="1"/>
           </p:cNvPicPr>
@@ -5091,7 +6458,7 @@
       </p:sp>
       <p:pic>
         <p:nvPicPr>
-          <p:cNvPr descr="supervised_learning_files/figure-pptx/unnamed-chunk-8-1.png" id="0" name="Picture 1"/>
+          <p:cNvPr descr="supervised_learning_files/figure-pptx/unnamed-chunk-9-1.png" id="0" name="Picture 1"/>
           <p:cNvPicPr>
             <a:picLocks noGrp="1" noChangeAspect="1"/>
           </p:cNvPicPr>
@@ -5170,195 +6537,6 @@
             <a:r>
               <a:rPr/>
               <a:t>This chart shows the “MVPs” (Most Valuable Predictors) selected by LASSO. Bigger values (further from zero) mean more impact on fuel efficiency.</a:t>
-            </a:r>
-          </a:p>
-        </p:txBody>
-      </p:sp>
-    </p:spTree>
-  </p:cSld>
-</p:sld>
-</file>
-
-<file path=ppt/slides/slide8.xml><?xml version="1.0" encoding="utf-8"?>
-<p:sld xmlns:a="http://schemas.openxmlformats.org/drawingml/2006/main" xmlns:r="http://schemas.openxmlformats.org/officeDocument/2006/relationships" xmlns:p="http://schemas.openxmlformats.org/presentationml/2006/main">
-  <p:cSld>
-    <p:spTree>
-      <p:nvGrpSpPr>
-        <p:cNvPr id="1" name=""/>
-        <p:cNvGrpSpPr/>
-        <p:nvPr/>
-      </p:nvGrpSpPr>
-      <p:grpSpPr>
-        <a:xfrm>
-          <a:off x="0" y="0"/>
-          <a:ext cx="0" cy="0"/>
-          <a:chOff x="0" y="0"/>
-          <a:chExt cx="0" cy="0"/>
-        </a:xfrm>
-      </p:grpSpPr>
-      <p:sp>
-        <p:nvSpPr>
-          <p:cNvPr id="2" name="Title 1"/>
-          <p:cNvSpPr>
-            <a:spLocks noGrp="1"/>
-          </p:cNvSpPr>
-          <p:nvPr>
-            <p:ph type="title"/>
-          </p:nvPr>
-        </p:nvSpPr>
-        <p:spPr/>
-        <p:txBody>
-          <a:bodyPr/>
-          <a:lstStyle/>
-          <a:p>
-            <a:pPr lvl="0" indent="0" marL="0">
-              <a:buNone/>
-            </a:pPr>
-            <a:r>
-              <a:rPr/>
-              <a:t>Model Performance Comparison</a:t>
-            </a:r>
-          </a:p>
-        </p:txBody>
-      </p:sp>
-      <p:sp>
-        <p:nvSpPr>
-          <p:cNvPr id="3" name="Content Placeholder 2"/>
-          <p:cNvSpPr>
-            <a:spLocks noGrp="1"/>
-          </p:cNvSpPr>
-          <p:nvPr>
-            <p:ph idx="1"/>
-          </p:nvPr>
-        </p:nvSpPr>
-        <p:spPr/>
-        <p:txBody>
-          <a:bodyPr/>
-          <a:lstStyle/>
-          <a:p>
-            <a:pPr lvl="0" indent="0" marL="0">
-              <a:spcBef>
-                <a:spcPts val="3000"/>
-              </a:spcBef>
-              <a:buNone/>
-            </a:pPr>
-            <a:r>
-              <a:rPr b="1"/>
-              <a:t>Comprehensive Metrics Analysis</a:t>
-            </a:r>
-          </a:p>
-          <a:p>
-            <a:pPr lvl="0" indent="0">
-              <a:buNone/>
-            </a:pPr>
-            <a:r>
-              <a:rPr>
-                <a:latin typeface="Courier"/>
-              </a:rPr>
-              <a:t>                     RMSE   MAE    R2
-Multiple Regression 2.663 2.214 0.807
-LASSO Regression    2.369 1.882 0.847</a:t>
-            </a:r>
-          </a:p>
-        </p:txBody>
-      </p:sp>
-    </p:spTree>
-  </p:cSld>
-</p:sld>
-</file>
-
-<file path=ppt/slides/slide9.xml><?xml version="1.0" encoding="utf-8"?>
-<p:sld xmlns:a="http://schemas.openxmlformats.org/drawingml/2006/main" xmlns:r="http://schemas.openxmlformats.org/officeDocument/2006/relationships" xmlns:p="http://schemas.openxmlformats.org/presentationml/2006/main">
-  <p:cSld>
-    <p:spTree>
-      <p:nvGrpSpPr>
-        <p:cNvPr id="1" name=""/>
-        <p:cNvGrpSpPr/>
-        <p:nvPr/>
-      </p:nvGrpSpPr>
-      <p:grpSpPr>
-        <a:xfrm>
-          <a:off x="0" y="0"/>
-          <a:ext cx="0" cy="0"/>
-          <a:chOff x="0" y="0"/>
-          <a:chExt cx="0" cy="0"/>
-        </a:xfrm>
-      </p:grpSpPr>
-      <p:sp>
-        <p:nvSpPr>
-          <p:cNvPr id="2" name="Title 1"/>
-          <p:cNvSpPr>
-            <a:spLocks noGrp="1"/>
-          </p:cNvSpPr>
-          <p:nvPr>
-            <p:ph type="title"/>
-          </p:nvPr>
-        </p:nvSpPr>
-        <p:spPr/>
-        <p:txBody>
-          <a:bodyPr/>
-          <a:lstStyle/>
-          <a:p>
-            <a:pPr lvl="0" indent="0" marL="0">
-              <a:buNone/>
-            </a:pPr>
-            <a:r>
-              <a:rPr/>
-              <a:t>Predicting Fuel Efficiency</a:t>
-            </a:r>
-          </a:p>
-        </p:txBody>
-      </p:sp>
-      <p:sp>
-        <p:nvSpPr>
-          <p:cNvPr id="3" name="Content Placeholder 2"/>
-          <p:cNvSpPr>
-            <a:spLocks noGrp="1"/>
-          </p:cNvSpPr>
-          <p:nvPr>
-            <p:ph idx="1"/>
-          </p:nvPr>
-        </p:nvSpPr>
-        <p:spPr/>
-        <p:txBody>
-          <a:bodyPr/>
-          <a:lstStyle/>
-          <a:p>
-            <a:pPr lvl="0" indent="0" marL="0">
-              <a:spcBef>
-                <a:spcPts val="3000"/>
-              </a:spcBef>
-              <a:buNone/>
-            </a:pPr>
-            <a:r>
-              <a:rPr b="1"/>
-              <a:t>Example: 6000 lbs Car</a:t>
-            </a:r>
-          </a:p>
-          <a:p>
-            <a:pPr lvl="0" indent="0" marL="0">
-              <a:buNone/>
-            </a:pPr>
-            <a:r>
-              <a:rPr b="1"/>
-              <a:t>Prediction:</a:t>
-            </a:r>
-            <a:r>
-              <a:rPr/>
-              <a:t> - For a 6000 lbs car, predicted MPG is 13.41 - 95% sure it’s between 0.93 and 25.88 MPG</a:t>
-            </a:r>
-          </a:p>
-          <a:p>
-            <a:pPr lvl="0" indent="0" marL="0">
-              <a:buNone/>
-            </a:pPr>
-            <a:r>
-              <a:rPr b="1"/>
-              <a:t>Important Note:</a:t>
-            </a:r>
-            <a:r>
-              <a:rPr/>
-              <a:t> - This is an estimate for a very heavy car - Our data doesn’t include cars this heavy - Predictions outside data range are less reliable</a:t>
             </a:r>
           </a:p>
         </p:txBody>

</xml_diff>